<commit_message>
🔄 chore(brand): sync brand tokens from brand-tokens@208312d
Full brand sync for dukestrategies. Removed misplaced company data
(profile, people, messaging, proposals, press-releases) from brand/ zone.
Updated PPTX slide templates and default.pptx; removed deprecated thumbnails
and old template versions.

Co-Authored-By: Claude Opus 4.6 <noreply@anthropic.com>
</commit_message>
<xml_diff>
--- a/companies/dukestrategies/brand/templates/pptx/default.pptx
+++ b/companies/dukestrategies/brand/templates/pptx/default.pptx
@@ -5218,7 +5218,7 @@
     <p:bg>
       <p:bgPr>
         <a:solidFill>
-          <a:srgbClr val="807F83"/>
+          <a:srgbClr val="2D2C2E"/>
         </a:solidFill>
       </p:bgPr>
     </p:bg>
@@ -5245,7 +5245,7 @@
         <p:spPr>
           <a:xfrm>
             <a:off x="0" y="0"/>
-            <a:ext cx="9144000" cy="126950"/>
+            <a:ext cx="9144000" cy="25301"/>
           </a:xfrm>
           <a:prstGeom prst="rect">
             <a:avLst/>
@@ -5314,7 +5314,7 @@
         <p:spPr>
           <a:xfrm>
             <a:off x="762000" y="2327225"/>
-            <a:ext cx="7772400" cy="1788021"/>
+            <a:ext cx="7772400" cy="894159"/>
           </a:xfrm>
           <a:prstGeom prst="rect">
             <a:avLst/>
@@ -5328,7 +5328,7 @@
           <a:p>
             <a:pPr algn="l" indent="0" marL="0">
               <a:lnSpc>
-                <a:spcPts val="7040"/>
+                <a:spcPts val="3520"/>
               </a:lnSpc>
               <a:spcBef>
                 <a:spcPts val="1200"/>
@@ -5336,7 +5336,7 @@
               <a:buNone/>
             </a:pPr>
             <a:r>
-              <a:rPr lang="en-US" sz="6400" dirty="0">
+              <a:rPr lang="en-US" sz="3200" dirty="0">
                 <a:solidFill>
                   <a:srgbClr val="FFFFFF"/>
                 </a:solidFill>
@@ -5346,12 +5346,12 @@
               </a:rPr>
               <a:t>Duke Strategies</a:t>
             </a:r>
-            <a:endParaRPr lang="en-US" sz="6400" dirty="0"/>
+            <a:endParaRPr lang="en-US" sz="3200" dirty="0"/>
           </a:p>
           <a:p>
             <a:pPr algn="l" indent="0" marL="0">
               <a:lnSpc>
-                <a:spcPts val="7040"/>
+                <a:spcPts val="3520"/>
               </a:lnSpc>
               <a:spcBef>
                 <a:spcPts val="1200"/>
@@ -5359,7 +5359,7 @@
               <a:buNone/>
             </a:pPr>
             <a:r>
-              <a:rPr lang="en-US" sz="6400" dirty="0">
+              <a:rPr lang="en-US" sz="3200" dirty="0">
                 <a:solidFill>
                   <a:srgbClr val="FFFFFF"/>
                 </a:solidFill>
@@ -5369,7 +5369,7 @@
               </a:rPr>
               <a:t>Template Library</a:t>
             </a:r>
-            <a:endParaRPr lang="en-US" sz="6400" dirty="0"/>
+            <a:endParaRPr lang="en-US" sz="3200" dirty="0"/>
           </a:p>
         </p:txBody>
       </p:sp>
@@ -5381,8 +5381,8 @@
         </p:nvSpPr>
         <p:spPr>
           <a:xfrm>
-            <a:off x="762000" y="4216747"/>
-            <a:ext cx="1524000" cy="38100"/>
+            <a:off x="762000" y="3322886"/>
+            <a:ext cx="1524000" cy="9525"/>
           </a:xfrm>
           <a:prstGeom prst="rect">
             <a:avLst/>
@@ -5411,7 +5411,7 @@
         </p:nvSpPr>
         <p:spPr>
           <a:xfrm>
-            <a:off x="762000" y="4457998"/>
+            <a:off x="762000" y="3535561"/>
             <a:ext cx="7772400" cy="171450"/>
           </a:xfrm>
           <a:prstGeom prst="rect">
@@ -5453,8 +5453,8 @@
         </p:nvSpPr>
         <p:spPr>
           <a:xfrm>
-            <a:off x="8023473" y="4629150"/>
-            <a:ext cx="624828" cy="133350"/>
+            <a:off x="7845772" y="4629150"/>
+            <a:ext cx="806083" cy="133350"/>
           </a:xfrm>
           <a:prstGeom prst="rect">
             <a:avLst/>
@@ -5478,7 +5478,7 @@
                 <a:ea typeface="Space Mono" pitchFamily="34" charset="-122"/>
                 <a:cs typeface="Space Mono" pitchFamily="34" charset="-120"/>
               </a:rPr>
-              <a:t>example.com</a:t>
+              <a:t>dukestrategies.eu</a:t>
             </a:r>
             <a:endParaRPr lang="en-US" sz="900" dirty="0"/>
           </a:p>
@@ -5518,7 +5518,7 @@
       </p:grpSpPr>
       <p:pic>
         <p:nvPicPr>
-          <p:cNvPr id="2" name="Image 0" descr="/Users/williammasquelier/Repositories/stromy-org/brand-tokens/clients/dukestrategies/templates/pptx/_processed/Nesciobrug.tinted-overlay.jpg">    </p:cNvPr>
+          <p:cNvPr id="2" name="Image 0" descr="/Users/williammasquelier/Repositories/stromy-org/brand-tokens/clients/dukestrategies/templates/pptx/_processed/Nesciobrug.bw-accent.jpg">    </p:cNvPr>
           <p:cNvPicPr>
             <a:picLocks noChangeAspect="1"/>
           </p:cNvPicPr>
@@ -5609,7 +5609,7 @@
             <a:r>
               <a:rPr lang="en-US" sz="2200" b="1" dirty="0">
                 <a:solidFill>
-                  <a:srgbClr val="807F83"/>
+                  <a:srgbClr val="2D2C2E"/>
                 </a:solidFill>
                 <a:latin typeface="Montserrat" pitchFamily="34" charset="0"/>
                 <a:ea typeface="Montserrat" pitchFamily="34" charset="-122"/>
@@ -5630,7 +5630,7 @@
         <p:spPr>
           <a:xfrm>
             <a:off x="4444901" y="1168152"/>
-            <a:ext cx="762000" cy="38100"/>
+            <a:ext cx="762000" cy="9525"/>
           </a:xfrm>
           <a:prstGeom prst="rect">
             <a:avLst/>
@@ -5659,7 +5659,7 @@
         </p:nvSpPr>
         <p:spPr>
           <a:xfrm>
-            <a:off x="4444901" y="1358652"/>
+            <a:off x="4444901" y="1330077"/>
             <a:ext cx="4274820" cy="487561"/>
           </a:xfrm>
           <a:prstGeom prst="rect">
@@ -5727,8 +5727,8 @@
         </p:nvSpPr>
         <p:spPr>
           <a:xfrm>
-            <a:off x="507950" y="4845100"/>
-            <a:ext cx="8127950" cy="19050"/>
+            <a:off x="507950" y="4859387"/>
+            <a:ext cx="8127950" cy="4763"/>
           </a:xfrm>
           <a:prstGeom prst="rect">
             <a:avLst/>
@@ -5928,7 +5928,7 @@
             <a:r>
               <a:rPr lang="en-US" sz="2200" b="1" dirty="0">
                 <a:solidFill>
-                  <a:srgbClr val="807F83"/>
+                  <a:srgbClr val="2D2C2E"/>
                 </a:solidFill>
                 <a:latin typeface="Montserrat" pitchFamily="34" charset="0"/>
                 <a:ea typeface="Montserrat" pitchFamily="34" charset="-122"/>
@@ -5970,7 +5970,7 @@
             <a:r>
               <a:rPr lang="en-US" sz="1100" b="1" dirty="0">
                 <a:solidFill>
-                  <a:srgbClr val="807F83"/>
+                  <a:srgbClr val="2D2C2E"/>
                 </a:solidFill>
                 <a:latin typeface="Montserrat" pitchFamily="34" charset="0"/>
                 <a:ea typeface="Montserrat" pitchFamily="34" charset="-122"/>
@@ -6124,7 +6124,7 @@
             <a:r>
               <a:rPr lang="en-US" sz="1100" b="1" dirty="0">
                 <a:solidFill>
-                  <a:srgbClr val="807F83"/>
+                  <a:srgbClr val="2D2C2E"/>
                 </a:solidFill>
                 <a:latin typeface="Montserrat" pitchFamily="34" charset="0"/>
                 <a:ea typeface="Montserrat" pitchFamily="34" charset="-122"/>
@@ -6226,8 +6226,8 @@
         </p:nvSpPr>
         <p:spPr>
           <a:xfrm>
-            <a:off x="507950" y="4845100"/>
-            <a:ext cx="8127950" cy="19050"/>
+            <a:off x="507950" y="4859387"/>
+            <a:ext cx="8127950" cy="4763"/>
           </a:xfrm>
           <a:prstGeom prst="rect">
             <a:avLst/>
@@ -6427,7 +6427,7 @@
             <a:r>
               <a:rPr lang="en-US" sz="2200" b="1" dirty="0">
                 <a:solidFill>
-                  <a:srgbClr val="807F83"/>
+                  <a:srgbClr val="2D2C2E"/>
                 </a:solidFill>
                 <a:latin typeface="Montserrat" pitchFamily="34" charset="0"/>
                 <a:ea typeface="Montserrat" pitchFamily="34" charset="-122"/>
@@ -6544,7 +6544,7 @@
             <a:r>
               <a:rPr lang="en-US" sz="1400" dirty="0">
                 <a:solidFill>
-                  <a:srgbClr val="807F83"/>
+                  <a:srgbClr val="2D2C2E"/>
                 </a:solidFill>
                 <a:latin typeface="Montserrat" pitchFamily="34" charset="0"/>
                 <a:ea typeface="Montserrat" pitchFamily="34" charset="-122"/>
@@ -6706,7 +6706,7 @@
             <a:r>
               <a:rPr lang="en-US" sz="1400" dirty="0">
                 <a:solidFill>
-                  <a:srgbClr val="807F83"/>
+                  <a:srgbClr val="2D2C2E"/>
                 </a:solidFill>
                 <a:latin typeface="Montserrat" pitchFamily="34" charset="0"/>
                 <a:ea typeface="Montserrat" pitchFamily="34" charset="-122"/>
@@ -6868,7 +6868,7 @@
             <a:r>
               <a:rPr lang="en-US" sz="1400" dirty="0">
                 <a:solidFill>
-                  <a:srgbClr val="807F83"/>
+                  <a:srgbClr val="2D2C2E"/>
                 </a:solidFill>
                 <a:latin typeface="Montserrat" pitchFamily="34" charset="0"/>
                 <a:ea typeface="Montserrat" pitchFamily="34" charset="-122"/>
@@ -6933,8 +6933,8 @@
         </p:nvSpPr>
         <p:spPr>
           <a:xfrm>
-            <a:off x="507950" y="4845100"/>
-            <a:ext cx="8127950" cy="19050"/>
+            <a:off x="507950" y="4859387"/>
+            <a:ext cx="8127950" cy="4763"/>
           </a:xfrm>
           <a:prstGeom prst="rect">
             <a:avLst/>
@@ -7134,7 +7134,7 @@
             <a:r>
               <a:rPr lang="en-US" sz="2200" b="1" dirty="0">
                 <a:solidFill>
-                  <a:srgbClr val="807F83"/>
+                  <a:srgbClr val="2D2C2E"/>
                 </a:solidFill>
                 <a:latin typeface="Montserrat" pitchFamily="34" charset="0"/>
                 <a:ea typeface="Montserrat" pitchFamily="34" charset="-122"/>
@@ -7155,7 +7155,7 @@
         <p:spPr>
           <a:xfrm>
             <a:off x="762000" y="1168152"/>
-            <a:ext cx="762000" cy="38100"/>
+            <a:ext cx="762000" cy="9525"/>
           </a:xfrm>
           <a:prstGeom prst="rect">
             <a:avLst/>
@@ -7184,7 +7184,7 @@
         </p:nvSpPr>
         <p:spPr>
           <a:xfrm>
-            <a:off x="762000" y="1358652"/>
+            <a:off x="762000" y="1330077"/>
             <a:ext cx="4922419" cy="670620"/>
           </a:xfrm>
           <a:prstGeom prst="rect">
@@ -7275,7 +7275,7 @@
         </p:nvSpPr>
         <p:spPr>
           <a:xfrm>
-            <a:off x="762000" y="2156222"/>
+            <a:off x="762000" y="2127647"/>
             <a:ext cx="4922419" cy="223540"/>
           </a:xfrm>
           <a:prstGeom prst="rect">
@@ -7434,7 +7434,7 @@
             <a:r>
               <a:rPr lang="en-US" sz="2800" dirty="0">
                 <a:solidFill>
-                  <a:srgbClr val="807F83"/>
+                  <a:srgbClr val="2D2C2E"/>
                 </a:solidFill>
                 <a:latin typeface="Montserrat" pitchFamily="34" charset="0"/>
                 <a:ea typeface="Montserrat" pitchFamily="34" charset="-122"/>
@@ -7499,8 +7499,8 @@
         </p:nvSpPr>
         <p:spPr>
           <a:xfrm>
-            <a:off x="507950" y="4845100"/>
-            <a:ext cx="8127950" cy="19050"/>
+            <a:off x="507950" y="4859387"/>
+            <a:ext cx="8127950" cy="4763"/>
           </a:xfrm>
           <a:prstGeom prst="rect">
             <a:avLst/>
@@ -7633,7 +7633,7 @@
       </p:grpSpPr>
       <p:pic>
         <p:nvPicPr>
-          <p:cNvPr id="2" name="Image 0" descr="/Users/williammasquelier/Repositories/stromy-org/brand-tokens/clients/dukestrategies/templates/pptx/_processed/Erasmusbrug_zwart.tinted-overlay.jpg">    </p:cNvPr>
+          <p:cNvPr id="2" name="Image 0" descr="/Users/williammasquelier/Repositories/stromy-org/brand-tokens/clients/dukestrategies/templates/pptx/_processed/Erasmusbrug_zwart.bw-accent.jpg">    </p:cNvPr>
           <p:cNvPicPr>
             <a:picLocks noChangeAspect="1"/>
           </p:cNvPicPr>
@@ -7682,7 +7682,7 @@
             <a:r>
               <a:rPr lang="en-US" sz="2000" b="1" dirty="0">
                 <a:solidFill>
-                  <a:srgbClr val="807F83"/>
+                  <a:srgbClr val="2D2C2E"/>
                 </a:solidFill>
                 <a:latin typeface="Montserrat" pitchFamily="34" charset="0"/>
                 <a:ea typeface="Montserrat" pitchFamily="34" charset="-122"/>
@@ -7826,8 +7826,8 @@
         </p:nvSpPr>
         <p:spPr>
           <a:xfrm>
-            <a:off x="507950" y="4845100"/>
-            <a:ext cx="8127950" cy="19050"/>
+            <a:off x="507950" y="4859387"/>
+            <a:ext cx="8127950" cy="4763"/>
           </a:xfrm>
           <a:prstGeom prst="rect">
             <a:avLst/>
@@ -8027,7 +8027,7 @@
             <a:r>
               <a:rPr lang="en-US" sz="2200" b="1" dirty="0">
                 <a:solidFill>
-                  <a:srgbClr val="807F83"/>
+                  <a:srgbClr val="2D2C2E"/>
                 </a:solidFill>
                 <a:latin typeface="Montserrat" pitchFamily="34" charset="0"/>
                 <a:ea typeface="Montserrat" pitchFamily="34" charset="-122"/>
@@ -8137,7 +8137,7 @@
             <a:r>
               <a:rPr lang="en-US" sz="1100" dirty="0">
                 <a:solidFill>
-                  <a:srgbClr val="807F83"/>
+                  <a:srgbClr val="2D2C2E"/>
                 </a:solidFill>
                 <a:latin typeface="Montserrat" pitchFamily="34" charset="0"/>
                 <a:ea typeface="Montserrat" pitchFamily="34" charset="-122"/>
@@ -8289,7 +8289,7 @@
             <a:r>
               <a:rPr lang="en-US" sz="1100" dirty="0">
                 <a:solidFill>
-                  <a:srgbClr val="807F83"/>
+                  <a:srgbClr val="2D2C2E"/>
                 </a:solidFill>
                 <a:latin typeface="Montserrat" pitchFamily="34" charset="0"/>
                 <a:ea typeface="Montserrat" pitchFamily="34" charset="-122"/>
@@ -8441,7 +8441,7 @@
             <a:r>
               <a:rPr lang="en-US" sz="1100" dirty="0">
                 <a:solidFill>
-                  <a:srgbClr val="807F83"/>
+                  <a:srgbClr val="2D2C2E"/>
                 </a:solidFill>
                 <a:latin typeface="Montserrat" pitchFamily="34" charset="0"/>
                 <a:ea typeface="Montserrat" pitchFamily="34" charset="-122"/>
@@ -8593,7 +8593,7 @@
             <a:r>
               <a:rPr lang="en-US" sz="1100" dirty="0">
                 <a:solidFill>
-                  <a:srgbClr val="807F83"/>
+                  <a:srgbClr val="2D2C2E"/>
                 </a:solidFill>
                 <a:latin typeface="Montserrat" pitchFamily="34" charset="0"/>
                 <a:ea typeface="Montserrat" pitchFamily="34" charset="-122"/>
@@ -8745,7 +8745,7 @@
             <a:r>
               <a:rPr lang="en-US" sz="1100" dirty="0">
                 <a:solidFill>
-                  <a:srgbClr val="807F83"/>
+                  <a:srgbClr val="2D2C2E"/>
                 </a:solidFill>
                 <a:latin typeface="Montserrat" pitchFamily="34" charset="0"/>
                 <a:ea typeface="Montserrat" pitchFamily="34" charset="-122"/>
@@ -8807,8 +8807,8 @@
         </p:nvSpPr>
         <p:spPr>
           <a:xfrm>
-            <a:off x="507950" y="4845100"/>
-            <a:ext cx="8127950" cy="19050"/>
+            <a:off x="507950" y="4859387"/>
+            <a:ext cx="8127950" cy="4763"/>
           </a:xfrm>
           <a:prstGeom prst="rect">
             <a:avLst/>
@@ -9008,7 +9008,7 @@
             <a:r>
               <a:rPr lang="en-US" sz="2200" b="1" dirty="0">
                 <a:solidFill>
-                  <a:srgbClr val="807F83"/>
+                  <a:srgbClr val="2D2C2E"/>
                 </a:solidFill>
                 <a:latin typeface="Montserrat" pitchFamily="34" charset="0"/>
                 <a:ea typeface="Montserrat" pitchFamily="34" charset="-122"/>
@@ -9081,7 +9081,7 @@
             <a:r>
               <a:rPr lang="en-US" sz="1200" dirty="0">
                 <a:solidFill>
-                  <a:srgbClr val="807F83"/>
+                  <a:srgbClr val="2D2C2E"/>
                 </a:solidFill>
                 <a:latin typeface="Montserrat" pitchFamily="34" charset="0"/>
                 <a:ea typeface="Montserrat" pitchFamily="34" charset="-122"/>
@@ -9196,7 +9196,7 @@
             <a:r>
               <a:rPr lang="en-US" sz="1200" dirty="0">
                 <a:solidFill>
-                  <a:srgbClr val="807F83"/>
+                  <a:srgbClr val="2D2C2E"/>
                 </a:solidFill>
                 <a:latin typeface="Montserrat" pitchFamily="34" charset="0"/>
                 <a:ea typeface="Montserrat" pitchFamily="34" charset="-122"/>
@@ -9311,7 +9311,7 @@
             <a:r>
               <a:rPr lang="en-US" sz="1200" dirty="0">
                 <a:solidFill>
-                  <a:srgbClr val="807F83"/>
+                  <a:srgbClr val="2D2C2E"/>
                 </a:solidFill>
                 <a:latin typeface="Montserrat" pitchFamily="34" charset="0"/>
                 <a:ea typeface="Montserrat" pitchFamily="34" charset="-122"/>
@@ -9426,7 +9426,7 @@
             <a:r>
               <a:rPr lang="en-US" sz="1200" dirty="0">
                 <a:solidFill>
-                  <a:srgbClr val="807F83"/>
+                  <a:srgbClr val="2D2C2E"/>
                 </a:solidFill>
                 <a:latin typeface="Montserrat" pitchFamily="34" charset="0"/>
                 <a:ea typeface="Montserrat" pitchFamily="34" charset="-122"/>
@@ -9541,7 +9541,7 @@
             <a:r>
               <a:rPr lang="en-US" sz="1200" dirty="0">
                 <a:solidFill>
-                  <a:srgbClr val="807F83"/>
+                  <a:srgbClr val="2D2C2E"/>
                 </a:solidFill>
                 <a:latin typeface="Montserrat" pitchFamily="34" charset="0"/>
                 <a:ea typeface="Montserrat" pitchFamily="34" charset="-122"/>
@@ -9603,8 +9603,8 @@
         </p:nvSpPr>
         <p:spPr>
           <a:xfrm>
-            <a:off x="507950" y="4845100"/>
-            <a:ext cx="8127950" cy="19050"/>
+            <a:off x="507950" y="4859387"/>
+            <a:ext cx="8127950" cy="4763"/>
           </a:xfrm>
           <a:prstGeom prst="rect">
             <a:avLst/>
@@ -9737,7 +9737,7 @@
       </p:grpSpPr>
       <p:pic>
         <p:nvPicPr>
-          <p:cNvPr id="2" name="Image 0" descr="/Users/williammasquelier/Repositories/stromy-org/brand-tokens/clients/dukestrategies/templates/pptx/_processed/Erasmusbrug_zwart.tinted-overlay.jpg">    </p:cNvPr>
+          <p:cNvPr id="2" name="Image 0" descr="/Users/williammasquelier/Repositories/stromy-org/brand-tokens/clients/dukestrategies/templates/pptx/_processed/Erasmusbrug_zwart.bw-accent.jpg">    </p:cNvPr>
           <p:cNvPicPr>
             <a:picLocks noChangeAspect="1"/>
           </p:cNvPicPr>
@@ -9815,7 +9815,7 @@
             </a:avLst>
           </a:prstGeom>
           <a:solidFill>
-            <a:srgbClr val="807F83"/>
+            <a:srgbClr val="2D2C2E"/>
           </a:solidFill>
           <a:ln/>
         </p:spPr>
@@ -9838,8 +9838,8 @@
         </p:nvSpPr>
         <p:spPr>
           <a:xfrm>
-            <a:off x="6349752" y="1061889"/>
-            <a:ext cx="1088136" cy="704850"/>
+            <a:off x="6341269" y="1061889"/>
+            <a:ext cx="1105442" cy="704850"/>
           </a:xfrm>
           <a:prstGeom prst="rect">
             <a:avLst/>
@@ -9863,7 +9863,7 @@
                 <a:ea typeface="Montserrat" pitchFamily="34" charset="-122"/>
                 <a:cs typeface="Montserrat" pitchFamily="34" charset="-120"/>
               </a:rPr>
-              <a:t>3.2x</a:t>
+              <a:t>7/10</a:t>
             </a:r>
             <a:endParaRPr lang="en-US" sz="4800" dirty="0"/>
           </a:p>
@@ -9877,8 +9877,8 @@
         </p:nvSpPr>
         <p:spPr>
           <a:xfrm>
-            <a:off x="6547693" y="1842939"/>
-            <a:ext cx="684487" cy="142875"/>
+            <a:off x="6341864" y="1842939"/>
+            <a:ext cx="1104227" cy="142875"/>
           </a:xfrm>
           <a:prstGeom prst="rect">
             <a:avLst/>
@@ -9905,7 +9905,7 @@
                 <a:ea typeface="Montserrat" pitchFamily="34" charset="-122"/>
                 <a:cs typeface="Montserrat" pitchFamily="34" charset="-120"/>
               </a:rPr>
-              <a:t>Average ROI</a:t>
+              <a:t>Committee Coverage</a:t>
             </a:r>
             <a:endParaRPr lang="en-US" sz="1000" dirty="0"/>
           </a:p>
@@ -9938,7 +9938,7 @@
             <a:r>
               <a:rPr lang="en-US" sz="1000" b="1" dirty="0">
                 <a:solidFill>
-                  <a:srgbClr val="807F83"/>
+                  <a:srgbClr val="2D2C2E"/>
                 </a:solidFill>
                 <a:latin typeface="Montserrat" pitchFamily="34" charset="0"/>
                 <a:ea typeface="Montserrat" pitchFamily="34" charset="-122"/>
@@ -10045,7 +10045,7 @@
             <a:r>
               <a:rPr lang="en-US" sz="1000" b="1" dirty="0">
                 <a:solidFill>
-                  <a:srgbClr val="807F83"/>
+                  <a:srgbClr val="2D2C2E"/>
                 </a:solidFill>
                 <a:latin typeface="Montserrat" pitchFamily="34" charset="0"/>
                 <a:ea typeface="Montserrat" pitchFamily="34" charset="-122"/>
@@ -10133,8 +10133,8 @@
         </p:nvSpPr>
         <p:spPr>
           <a:xfrm>
-            <a:off x="507950" y="4845100"/>
-            <a:ext cx="8127950" cy="19050"/>
+            <a:off x="507950" y="4859387"/>
+            <a:ext cx="8127950" cy="4763"/>
           </a:xfrm>
           <a:prstGeom prst="rect">
             <a:avLst/>
@@ -10247,7 +10247,7 @@
     <p:bg>
       <p:bgPr>
         <a:solidFill>
-          <a:srgbClr val="807F83"/>
+          <a:srgbClr val="2D2C2E"/>
         </a:solidFill>
       </p:bgPr>
     </p:bg>
@@ -11159,7 +11159,7 @@
             <a:r>
               <a:rPr lang="en-US" sz="2200" b="1" dirty="0">
                 <a:solidFill>
-                  <a:srgbClr val="807F83"/>
+                  <a:srgbClr val="2D2C2E"/>
                 </a:solidFill>
                 <a:latin typeface="Montserrat" pitchFamily="34" charset="0"/>
                 <a:ea typeface="Montserrat" pitchFamily="34" charset="-122"/>
@@ -11251,7 +11251,7 @@
             <a:r>
               <a:rPr lang="en-US" sz="3600" dirty="0">
                 <a:solidFill>
-                  <a:srgbClr val="807F83"/>
+                  <a:srgbClr val="2D2C2E"/>
                 </a:solidFill>
                 <a:latin typeface="Montserrat" pitchFamily="34" charset="0"/>
                 <a:ea typeface="Montserrat" pitchFamily="34" charset="-122"/>
@@ -11427,7 +11427,7 @@
             <a:r>
               <a:rPr lang="en-US" sz="3600" dirty="0">
                 <a:solidFill>
-                  <a:srgbClr val="807F83"/>
+                  <a:srgbClr val="2D2C2E"/>
                 </a:solidFill>
                 <a:latin typeface="Montserrat" pitchFamily="34" charset="0"/>
                 <a:ea typeface="Montserrat" pitchFamily="34" charset="-122"/>
@@ -11603,7 +11603,7 @@
             <a:r>
               <a:rPr lang="en-US" sz="3600" dirty="0">
                 <a:solidFill>
-                  <a:srgbClr val="807F83"/>
+                  <a:srgbClr val="2D2C2E"/>
                 </a:solidFill>
                 <a:latin typeface="Montserrat" pitchFamily="34" charset="0"/>
                 <a:ea typeface="Montserrat" pitchFamily="34" charset="-122"/>
@@ -11707,8 +11707,8 @@
         </p:nvSpPr>
         <p:spPr>
           <a:xfrm>
-            <a:off x="507950" y="4845100"/>
-            <a:ext cx="8127950" cy="19050"/>
+            <a:off x="507950" y="4859387"/>
+            <a:ext cx="8127950" cy="4763"/>
           </a:xfrm>
           <a:prstGeom prst="rect">
             <a:avLst/>
@@ -11821,7 +11821,7 @@
     <p:bg>
       <p:bgPr>
         <a:solidFill>
-          <a:srgbClr val="807F83"/>
+          <a:srgbClr val="2D2C2E"/>
         </a:solidFill>
       </p:bgPr>
     </p:bg>
@@ -11955,7 +11955,7 @@
         <p:spPr>
           <a:xfrm>
             <a:off x="762000" y="2601367"/>
-            <a:ext cx="1269950" cy="38100"/>
+            <a:ext cx="1269950" cy="9525"/>
           </a:xfrm>
           <a:prstGeom prst="rect">
             <a:avLst/>
@@ -11984,7 +11984,7 @@
         </p:nvSpPr>
         <p:spPr>
           <a:xfrm>
-            <a:off x="762000" y="2842617"/>
+            <a:off x="762000" y="2814042"/>
             <a:ext cx="3627069" cy="161925"/>
           </a:xfrm>
           <a:prstGeom prst="rect">
@@ -12026,7 +12026,7 @@
         </p:nvSpPr>
         <p:spPr>
           <a:xfrm>
-            <a:off x="762000" y="3106043"/>
+            <a:off x="762000" y="3077468"/>
             <a:ext cx="3627069" cy="133350"/>
           </a:xfrm>
           <a:prstGeom prst="rect">
@@ -12054,7 +12054,7 @@
                 <a:ea typeface="Space Mono" pitchFamily="34" charset="-122"/>
                 <a:cs typeface="Space Mono" pitchFamily="34" charset="-120"/>
               </a:rPr>
-              <a:t>example.com</a:t>
+              <a:t>dukestrategies.eu</a:t>
             </a:r>
             <a:endParaRPr lang="en-US" sz="900" dirty="0"/>
           </a:p>
@@ -12085,7 +12085,7 @@
       </p:sp>
       <p:pic>
         <p:nvPicPr>
-          <p:cNvPr id="8" name="Image 0" descr="/Users/williammasquelier/Repositories/stromy-org/brand-tokens/clients/dukestrategies/templates/pptx/_processed/Erasmusbrug_zwart.tinted-overlay.jpg">    </p:cNvPr>
+          <p:cNvPr id="8" name="Image 0" descr="/Users/williammasquelier/Repositories/stromy-org/brand-tokens/clients/dukestrategies/templates/pptx/_processed/Erasmusbrug_zwart.bw-accent.jpg">    </p:cNvPr>
           <p:cNvPicPr>
             <a:picLocks noChangeAspect="1"/>
           </p:cNvPicPr>
@@ -12166,7 +12166,7 @@
             <a:r>
               <a:rPr lang="en-US" sz="1800" b="1" dirty="0">
                 <a:solidFill>
-                  <a:srgbClr val="807F83"/>
+                  <a:srgbClr val="2D2C2E"/>
                 </a:solidFill>
                 <a:latin typeface="Montserrat" pitchFamily="34" charset="0"/>
                 <a:ea typeface="Montserrat" pitchFamily="34" charset="-122"/>
@@ -12786,7 +12786,7 @@
             <a:r>
               <a:rPr lang="en-US" sz="2200" b="1" dirty="0">
                 <a:solidFill>
-                  <a:srgbClr val="807F83"/>
+                  <a:srgbClr val="2D2C2E"/>
                 </a:solidFill>
                 <a:latin typeface="Montserrat" pitchFamily="34" charset="0"/>
                 <a:ea typeface="Montserrat" pitchFamily="34" charset="-122"/>
@@ -13077,13 +13077,13 @@
             <a:r>
               <a:rPr lang="en-US" sz="1000" dirty="0">
                 <a:solidFill>
-                  <a:srgbClr val="807F83"/>
-                </a:solidFill>
-                <a:latin typeface="Montserrat" pitchFamily="34" charset="0"/>
-                <a:ea typeface="Montserrat" pitchFamily="34" charset="-122"/>
-                <a:cs typeface="Montserrat" pitchFamily="34" charset="-120"/>
-              </a:rPr>
-              <a:t>Digital Transformation</a:t>
+                  <a:srgbClr val="2D2C2E"/>
+                </a:solidFill>
+                <a:latin typeface="Montserrat" pitchFamily="34" charset="0"/>
+                <a:ea typeface="Montserrat" pitchFamily="34" charset="-122"/>
+                <a:cs typeface="Montserrat" pitchFamily="34" charset="-120"/>
+              </a:rPr>
+              <a:t>Stakeholder Mapping</a:t>
             </a:r>
             <a:endParaRPr lang="en-US" sz="1000" dirty="0"/>
           </a:p>
@@ -13194,13 +13194,13 @@
             <a:r>
               <a:rPr lang="en-US" sz="1000" dirty="0">
                 <a:solidFill>
-                  <a:srgbClr val="807F83"/>
+                  <a:srgbClr val="2D2C2E"/>
                 </a:solidFill>
                 <a:latin typeface="Space Mono" pitchFamily="34" charset="0"/>
                 <a:ea typeface="Space Mono" pitchFamily="34" charset="-122"/>
                 <a:cs typeface="Space Mono" pitchFamily="34" charset="-120"/>
               </a:rPr>
-              <a:t>$1.2M</a:t>
+              <a:t>$95K</a:t>
             </a:r>
             <a:endParaRPr lang="en-US" sz="1000" dirty="0"/>
           </a:p>
@@ -13263,13 +13263,13 @@
             <a:r>
               <a:rPr lang="en-US" sz="1000" dirty="0">
                 <a:solidFill>
-                  <a:srgbClr val="807F83"/>
-                </a:solidFill>
-                <a:latin typeface="Montserrat" pitchFamily="34" charset="0"/>
-                <a:ea typeface="Montserrat" pitchFamily="34" charset="-122"/>
-                <a:cs typeface="Montserrat" pitchFamily="34" charset="-120"/>
-              </a:rPr>
-              <a:t>Data Strategy</a:t>
+                  <a:srgbClr val="2D2C2E"/>
+                </a:solidFill>
+                <a:latin typeface="Montserrat" pitchFamily="34" charset="0"/>
+                <a:ea typeface="Montserrat" pitchFamily="34" charset="-122"/>
+                <a:cs typeface="Montserrat" pitchFamily="34" charset="-120"/>
+              </a:rPr>
+              <a:t>Legislative Monitoring</a:t>
             </a:r>
             <a:endParaRPr lang="en-US" sz="1000" dirty="0"/>
           </a:p>
@@ -13347,7 +13347,7 @@
                 <a:ea typeface="Montserrat" pitchFamily="34" charset="-122"/>
                 <a:cs typeface="Montserrat" pitchFamily="34" charset="-120"/>
               </a:rPr>
-              <a:t>Planned</a:t>
+              <a:t>Ongoing</a:t>
             </a:r>
             <a:endParaRPr lang="en-US" sz="1000" dirty="0"/>
           </a:p>
@@ -13380,13 +13380,13 @@
             <a:r>
               <a:rPr lang="en-US" sz="1000" dirty="0">
                 <a:solidFill>
-                  <a:srgbClr val="807F83"/>
+                  <a:srgbClr val="2D2C2E"/>
                 </a:solidFill>
                 <a:latin typeface="Space Mono" pitchFamily="34" charset="0"/>
                 <a:ea typeface="Space Mono" pitchFamily="34" charset="-122"/>
                 <a:cs typeface="Space Mono" pitchFamily="34" charset="-120"/>
               </a:rPr>
-              <a:t>$680K</a:t>
+              <a:t>$60K</a:t>
             </a:r>
             <a:endParaRPr lang="en-US" sz="1000" dirty="0"/>
           </a:p>
@@ -13449,13 +13449,13 @@
             <a:r>
               <a:rPr lang="en-US" sz="1000" dirty="0">
                 <a:solidFill>
-                  <a:srgbClr val="807F83"/>
-                </a:solidFill>
-                <a:latin typeface="Montserrat" pitchFamily="34" charset="0"/>
-                <a:ea typeface="Montserrat" pitchFamily="34" charset="-122"/>
-                <a:cs typeface="Montserrat" pitchFamily="34" charset="-120"/>
-              </a:rPr>
-              <a:t>Process Optimization</a:t>
+                  <a:srgbClr val="2D2C2E"/>
+                </a:solidFill>
+                <a:latin typeface="Montserrat" pitchFamily="34" charset="0"/>
+                <a:ea typeface="Montserrat" pitchFamily="34" charset="-122"/>
+                <a:cs typeface="Montserrat" pitchFamily="34" charset="-120"/>
+              </a:rPr>
+              <a:t>Coalition Building</a:t>
             </a:r>
             <a:endParaRPr lang="en-US" sz="1000" dirty="0"/>
           </a:p>
@@ -13566,13 +13566,13 @@
             <a:r>
               <a:rPr lang="en-US" sz="1000" dirty="0">
                 <a:solidFill>
-                  <a:srgbClr val="807F83"/>
+                  <a:srgbClr val="2D2C2E"/>
                 </a:solidFill>
                 <a:latin typeface="Space Mono" pitchFamily="34" charset="0"/>
                 <a:ea typeface="Space Mono" pitchFamily="34" charset="-122"/>
                 <a:cs typeface="Space Mono" pitchFamily="34" charset="-120"/>
               </a:rPr>
-              <a:t>$450K</a:t>
+              <a:t>$120K</a:t>
             </a:r>
             <a:endParaRPr lang="en-US" sz="1000" dirty="0"/>
           </a:p>
@@ -13635,13 +13635,13 @@
             <a:r>
               <a:rPr lang="en-US" sz="1000" dirty="0">
                 <a:solidFill>
-                  <a:srgbClr val="807F83"/>
-                </a:solidFill>
-                <a:latin typeface="Montserrat" pitchFamily="34" charset="0"/>
-                <a:ea typeface="Montserrat" pitchFamily="34" charset="-122"/>
-                <a:cs typeface="Montserrat" pitchFamily="34" charset="-120"/>
-              </a:rPr>
-              <a:t>Change Management</a:t>
+                  <a:srgbClr val="2D2C2E"/>
+                </a:solidFill>
+                <a:latin typeface="Montserrat" pitchFamily="34" charset="0"/>
+                <a:ea typeface="Montserrat" pitchFamily="34" charset="-122"/>
+                <a:cs typeface="Montserrat" pitchFamily="34" charset="-120"/>
+              </a:rPr>
+              <a:t>Media Strategy</a:t>
             </a:r>
             <a:endParaRPr lang="en-US" sz="1000" dirty="0"/>
           </a:p>
@@ -13752,13 +13752,13 @@
             <a:r>
               <a:rPr lang="en-US" sz="1000" dirty="0">
                 <a:solidFill>
-                  <a:srgbClr val="807F83"/>
+                  <a:srgbClr val="2D2C2E"/>
                 </a:solidFill>
                 <a:latin typeface="Space Mono" pitchFamily="34" charset="0"/>
                 <a:ea typeface="Space Mono" pitchFamily="34" charset="-122"/>
                 <a:cs typeface="Space Mono" pitchFamily="34" charset="-120"/>
               </a:rPr>
-              <a:t>$320K</a:t>
+              <a:t>$85K</a:t>
             </a:r>
             <a:endParaRPr lang="en-US" sz="1000" dirty="0"/>
           </a:p>
@@ -13814,8 +13814,8 @@
         </p:nvSpPr>
         <p:spPr>
           <a:xfrm>
-            <a:off x="507950" y="4845100"/>
-            <a:ext cx="8127950" cy="19050"/>
+            <a:off x="507950" y="4859387"/>
+            <a:ext cx="8127950" cy="4763"/>
           </a:xfrm>
           <a:prstGeom prst="rect">
             <a:avLst/>
@@ -13928,7 +13928,7 @@
     <p:bg>
       <p:bgPr>
         <a:solidFill>
-          <a:srgbClr val="807F83"/>
+          <a:srgbClr val="2D2C2E"/>
         </a:solidFill>
       </p:bgPr>
     </p:bg>
@@ -13954,8 +13954,8 @@
         </p:nvSpPr>
         <p:spPr>
           <a:xfrm>
-            <a:off x="1333551" y="1506587"/>
-            <a:ext cx="6476899" cy="1219200"/>
+            <a:off x="1333551" y="1724099"/>
+            <a:ext cx="6476899" cy="812750"/>
           </a:xfrm>
           <a:prstGeom prst="rect">
             <a:avLst/>
@@ -13969,12 +13969,12 @@
           <a:p>
             <a:pPr algn="ctr" indent="0" marL="0">
               <a:lnSpc>
-                <a:spcPts val="9600"/>
+                <a:spcPts val="6400"/>
               </a:lnSpc>
               <a:buNone/>
             </a:pPr>
             <a:r>
-              <a:rPr lang="en-US" sz="9600" dirty="0">
+              <a:rPr lang="en-US" sz="6400" dirty="0">
                 <a:solidFill>
                   <a:srgbClr val="FF7F66"/>
                 </a:solidFill>
@@ -13984,7 +13984,7 @@
               </a:rPr>
               <a:t>7 of 10</a:t>
             </a:r>
-            <a:endParaRPr lang="en-US" sz="9600" dirty="0"/>
+            <a:endParaRPr lang="en-US" sz="6400" dirty="0"/>
           </a:p>
         </p:txBody>
       </p:sp>
@@ -13996,7 +13996,7 @@
         </p:nvSpPr>
         <p:spPr>
           <a:xfrm>
-            <a:off x="1333551" y="2878187"/>
+            <a:off x="1333551" y="2689250"/>
             <a:ext cx="6476899" cy="295275"/>
           </a:xfrm>
           <a:prstGeom prst="rect">
@@ -14038,8 +14038,8 @@
         </p:nvSpPr>
         <p:spPr>
           <a:xfrm>
-            <a:off x="1397050" y="3274963"/>
-            <a:ext cx="762000" cy="38100"/>
+            <a:off x="1397050" y="3086026"/>
+            <a:ext cx="762000" cy="9525"/>
           </a:xfrm>
           <a:prstGeom prst="rect">
             <a:avLst/>
@@ -14068,7 +14068,7 @@
         </p:nvSpPr>
         <p:spPr>
           <a:xfrm>
-            <a:off x="1333551" y="3465463"/>
+            <a:off x="1333551" y="3247951"/>
             <a:ext cx="6476899" cy="171450"/>
           </a:xfrm>
           <a:prstGeom prst="rect">
@@ -14116,7 +14116,7 @@
     <p:bg>
       <p:bgPr>
         <a:solidFill>
-          <a:srgbClr val="807F83"/>
+          <a:srgbClr val="2D2C2E"/>
         </a:solidFill>
       </p:bgPr>
     </p:bg>
@@ -14223,8 +14223,8 @@
         </p:nvSpPr>
         <p:spPr>
           <a:xfrm>
-            <a:off x="2567199" y="2336497"/>
-            <a:ext cx="1139750" cy="704850"/>
+            <a:off x="2605338" y="2336497"/>
+            <a:ext cx="1105442" cy="704850"/>
           </a:xfrm>
           <a:prstGeom prst="rect">
             <a:avLst/>
@@ -14248,7 +14248,7 @@
                 <a:ea typeface="Montserrat" pitchFamily="34" charset="-122"/>
                 <a:cs typeface="Montserrat" pitchFamily="34" charset="-120"/>
               </a:rPr>
-              <a:t>47%</a:t>
+              <a:t>2/10</a:t>
             </a:r>
             <a:endParaRPr lang="en-US" sz="4800" dirty="0"/>
           </a:p>
@@ -14262,8 +14262,8 @@
         </p:nvSpPr>
         <p:spPr>
           <a:xfrm>
-            <a:off x="2567199" y="3092098"/>
-            <a:ext cx="1139750" cy="142875"/>
+            <a:off x="2605338" y="3092098"/>
+            <a:ext cx="1105442" cy="142875"/>
           </a:xfrm>
           <a:prstGeom prst="rect">
             <a:avLst/>
@@ -14304,7 +14304,7 @@
         </p:nvSpPr>
         <p:spPr>
           <a:xfrm>
-            <a:off x="4203725" y="2518961"/>
+            <a:off x="4207892" y="2518961"/>
             <a:ext cx="466344" cy="533400"/>
           </a:xfrm>
           <a:prstGeom prst="rect">
@@ -14343,8 +14343,8 @@
         </p:nvSpPr>
         <p:spPr>
           <a:xfrm>
-            <a:off x="5154908" y="2250772"/>
-            <a:ext cx="1424687" cy="876300"/>
+            <a:off x="5159495" y="2250772"/>
+            <a:ext cx="1381878" cy="876300"/>
           </a:xfrm>
           <a:prstGeom prst="rect">
             <a:avLst/>
@@ -14368,7 +14368,7 @@
                 <a:ea typeface="Montserrat" pitchFamily="34" charset="-122"/>
                 <a:cs typeface="Montserrat" pitchFamily="34" charset="-120"/>
               </a:rPr>
-              <a:t>92%</a:t>
+              <a:t>7/10</a:t>
             </a:r>
             <a:endParaRPr lang="en-US" sz="6000" dirty="0"/>
           </a:p>
@@ -14382,8 +14382,8 @@
         </p:nvSpPr>
         <p:spPr>
           <a:xfrm>
-            <a:off x="5154908" y="3177823"/>
-            <a:ext cx="1424687" cy="142875"/>
+            <a:off x="5159495" y="3177823"/>
+            <a:ext cx="1381878" cy="142875"/>
           </a:xfrm>
           <a:prstGeom prst="rect">
             <a:avLst/>
@@ -14424,8 +14424,8 @@
         </p:nvSpPr>
         <p:spPr>
           <a:xfrm>
-            <a:off x="2786170" y="4219575"/>
-            <a:ext cx="3571661" cy="161925"/>
+            <a:off x="3114827" y="4219575"/>
+            <a:ext cx="2914346" cy="161925"/>
           </a:xfrm>
           <a:prstGeom prst="rect">
             <a:avLst/>
@@ -14449,7 +14449,7 @@
                 <a:ea typeface="Montserrat" pitchFamily="34" charset="-122"/>
                 <a:cs typeface="Montserrat" pitchFamily="34" charset="-120"/>
               </a:rPr>
-              <a:t>Customer satisfaction improvement after 6-month engagement</a:t>
+              <a:t>Target committee members engaged over 6 months</a:t>
             </a:r>
             <a:endParaRPr lang="en-US" sz="1100" dirty="0"/>
           </a:p>
@@ -14556,7 +14556,7 @@
             <a:r>
               <a:rPr lang="en-US" sz="2200" b="1" dirty="0">
                 <a:solidFill>
-                  <a:srgbClr val="807F83"/>
+                  <a:srgbClr val="2D2C2E"/>
                 </a:solidFill>
                 <a:latin typeface="Montserrat" pitchFamily="34" charset="0"/>
                 <a:ea typeface="Montserrat" pitchFamily="34" charset="-122"/>
@@ -14691,13 +14691,13 @@
             <a:r>
               <a:rPr lang="en-US" sz="1000" dirty="0">
                 <a:solidFill>
-                  <a:srgbClr val="807F83"/>
-                </a:solidFill>
-                <a:latin typeface="Montserrat" pitchFamily="34" charset="0"/>
-                <a:ea typeface="Montserrat" pitchFamily="34" charset="-122"/>
-                <a:cs typeface="Montserrat" pitchFamily="34" charset="-120"/>
-              </a:rPr>
-              <a:t>Digital Platform Migration</a:t>
+                  <a:srgbClr val="2D2C2E"/>
+                </a:solidFill>
+                <a:latin typeface="Montserrat" pitchFamily="34" charset="0"/>
+                <a:ea typeface="Montserrat" pitchFamily="34" charset="-122"/>
+                <a:cs typeface="Montserrat" pitchFamily="34" charset="-120"/>
+              </a:rPr>
+              <a:t>Stakeholder engagement plan</a:t>
             </a:r>
             <a:endParaRPr lang="en-US" sz="1000" dirty="0"/>
           </a:p>
@@ -14775,7 +14775,7 @@
                 <a:ea typeface="Montserrat" pitchFamily="34" charset="-122"/>
                 <a:cs typeface="Montserrat" pitchFamily="34" charset="-120"/>
               </a:rPr>
-              <a:t>Phase 2 of 3 complete</a:t>
+              <a:t>42 mapped, 18 engaged</a:t>
             </a:r>
             <a:endParaRPr lang="en-US" sz="900" dirty="0"/>
           </a:p>
@@ -14870,13 +14870,13 @@
             <a:r>
               <a:rPr lang="en-US" sz="1000" dirty="0">
                 <a:solidFill>
-                  <a:srgbClr val="807F83"/>
-                </a:solidFill>
-                <a:latin typeface="Montserrat" pitchFamily="34" charset="0"/>
-                <a:ea typeface="Montserrat" pitchFamily="34" charset="-122"/>
-                <a:cs typeface="Montserrat" pitchFamily="34" charset="-120"/>
-              </a:rPr>
-              <a:t>Data Governance Framework</a:t>
+                  <a:srgbClr val="2D2C2E"/>
+                </a:solidFill>
+                <a:latin typeface="Montserrat" pitchFamily="34" charset="0"/>
+                <a:ea typeface="Montserrat" pitchFamily="34" charset="-122"/>
+                <a:cs typeface="Montserrat" pitchFamily="34" charset="-120"/>
+              </a:rPr>
+              <a:t>Media monitoring dashboard</a:t>
             </a:r>
             <a:endParaRPr lang="en-US" sz="1000" dirty="0"/>
           </a:p>
@@ -14954,7 +14954,7 @@
                 <a:ea typeface="Montserrat" pitchFamily="34" charset="-122"/>
                 <a:cs typeface="Montserrat" pitchFamily="34" charset="-120"/>
               </a:rPr>
-              <a:t>Resource gap identified</a:t>
+              <a:t>Data feed delayed</a:t>
             </a:r>
             <a:endParaRPr lang="en-US" sz="900" dirty="0"/>
           </a:p>
@@ -15049,13 +15049,13 @@
             <a:r>
               <a:rPr lang="en-US" sz="1000" dirty="0">
                 <a:solidFill>
-                  <a:srgbClr val="807F83"/>
-                </a:solidFill>
-                <a:latin typeface="Montserrat" pitchFamily="34" charset="0"/>
-                <a:ea typeface="Montserrat" pitchFamily="34" charset="-122"/>
-                <a:cs typeface="Montserrat" pitchFamily="34" charset="-120"/>
-              </a:rPr>
-              <a:t>Process Automation</a:t>
+                  <a:srgbClr val="2D2C2E"/>
+                </a:solidFill>
+                <a:latin typeface="Montserrat" pitchFamily="34" charset="0"/>
+                <a:ea typeface="Montserrat" pitchFamily="34" charset="-122"/>
+                <a:cs typeface="Montserrat" pitchFamily="34" charset="-120"/>
+              </a:rPr>
+              <a:t>Coalition partner outreach</a:t>
             </a:r>
             <a:endParaRPr lang="en-US" sz="1000" dirty="0"/>
           </a:p>
@@ -15133,7 +15133,7 @@
                 <a:ea typeface="Montserrat" pitchFamily="34" charset="-122"/>
                 <a:cs typeface="Montserrat" pitchFamily="34" charset="-120"/>
               </a:rPr>
-              <a:t>Ahead of schedule</a:t>
+              <a:t>8 of 12 confirmed</a:t>
             </a:r>
             <a:endParaRPr lang="en-US" sz="900" dirty="0"/>
           </a:p>
@@ -15228,13 +15228,13 @@
             <a:r>
               <a:rPr lang="en-US" sz="1000" dirty="0">
                 <a:solidFill>
-                  <a:srgbClr val="807F83"/>
-                </a:solidFill>
-                <a:latin typeface="Montserrat" pitchFamily="34" charset="0"/>
-                <a:ea typeface="Montserrat" pitchFamily="34" charset="-122"/>
-                <a:cs typeface="Montserrat" pitchFamily="34" charset="-120"/>
-              </a:rPr>
-              <a:t>Legacy System Retirement</a:t>
+                  <a:srgbClr val="2D2C2E"/>
+                </a:solidFill>
+                <a:latin typeface="Montserrat" pitchFamily="34" charset="0"/>
+                <a:ea typeface="Montserrat" pitchFamily="34" charset="-122"/>
+                <a:cs typeface="Montserrat" pitchFamily="34" charset="-120"/>
+              </a:rPr>
+              <a:t>Parliamentary submission</a:t>
             </a:r>
             <a:endParaRPr lang="en-US" sz="1000" dirty="0"/>
           </a:p>
@@ -15312,7 +15312,7 @@
                 <a:ea typeface="Montserrat" pitchFamily="34" charset="-122"/>
                 <a:cs typeface="Montserrat" pitchFamily="34" charset="-120"/>
               </a:rPr>
-              <a:t>Dependency on vendor</a:t>
+              <a:t>Awaiting committee date</a:t>
             </a:r>
             <a:endParaRPr lang="en-US" sz="900" dirty="0"/>
           </a:p>
@@ -15407,13 +15407,13 @@
             <a:r>
               <a:rPr lang="en-US" sz="1000" dirty="0">
                 <a:solidFill>
-                  <a:srgbClr val="807F83"/>
-                </a:solidFill>
-                <a:latin typeface="Montserrat" pitchFamily="34" charset="0"/>
-                <a:ea typeface="Montserrat" pitchFamily="34" charset="-122"/>
-                <a:cs typeface="Montserrat" pitchFamily="34" charset="-120"/>
-              </a:rPr>
-              <a:t>Change Management Program</a:t>
+                  <a:srgbClr val="2D2C2E"/>
+                </a:solidFill>
+                <a:latin typeface="Montserrat" pitchFamily="34" charset="0"/>
+                <a:ea typeface="Montserrat" pitchFamily="34" charset="-122"/>
+                <a:cs typeface="Montserrat" pitchFamily="34" charset="-120"/>
+              </a:rPr>
+              <a:t>Narrative testing</a:t>
             </a:r>
             <a:endParaRPr lang="en-US" sz="1000" dirty="0"/>
           </a:p>
@@ -15491,7 +15491,7 @@
                 <a:ea typeface="Montserrat" pitchFamily="34" charset="-122"/>
                 <a:cs typeface="Montserrat" pitchFamily="34" charset="-120"/>
               </a:rPr>
-              <a:t>Training 80% complete</a:t>
+              <a:t>Focus groups complete</a:t>
             </a:r>
             <a:endParaRPr lang="en-US" sz="900" dirty="0"/>
           </a:p>
@@ -15505,8 +15505,8 @@
         </p:nvSpPr>
         <p:spPr>
           <a:xfrm>
-            <a:off x="507950" y="4845100"/>
-            <a:ext cx="8127950" cy="19050"/>
+            <a:off x="507950" y="4859387"/>
+            <a:ext cx="8127950" cy="4763"/>
           </a:xfrm>
           <a:prstGeom prst="rect">
             <a:avLst/>
@@ -15781,7 +15781,7 @@
             <a:r>
               <a:rPr lang="en-US" sz="2000" b="1" dirty="0">
                 <a:solidFill>
-                  <a:srgbClr val="807F83"/>
+                  <a:srgbClr val="2D2C2E"/>
                 </a:solidFill>
                 <a:latin typeface="Montserrat" pitchFamily="34" charset="0"/>
                 <a:ea typeface="Montserrat" pitchFamily="34" charset="-122"/>
@@ -15802,7 +15802,7 @@
         <p:spPr>
           <a:xfrm>
             <a:off x="5334149" y="1149102"/>
-            <a:ext cx="634901" cy="38100"/>
+            <a:ext cx="634901" cy="9525"/>
           </a:xfrm>
           <a:prstGeom prst="rect">
             <a:avLst/>
@@ -15831,7 +15831,7 @@
         </p:nvSpPr>
         <p:spPr>
           <a:xfrm>
-            <a:off x="5334149" y="1314152"/>
+            <a:off x="5334149" y="1285577"/>
             <a:ext cx="3367939" cy="447080"/>
           </a:xfrm>
           <a:prstGeom prst="rect">
@@ -15876,8 +15876,8 @@
         </p:nvSpPr>
         <p:spPr>
           <a:xfrm>
-            <a:off x="507950" y="4845100"/>
-            <a:ext cx="8127950" cy="19050"/>
+            <a:off x="507950" y="4859387"/>
+            <a:ext cx="8127950" cy="4763"/>
           </a:xfrm>
           <a:prstGeom prst="rect">
             <a:avLst/>
@@ -16077,7 +16077,7 @@
             <a:r>
               <a:rPr lang="en-US" sz="2000" b="1" dirty="0">
                 <a:solidFill>
-                  <a:srgbClr val="807F83"/>
+                  <a:srgbClr val="2D2C2E"/>
                 </a:solidFill>
                 <a:latin typeface="Montserrat" pitchFamily="34" charset="0"/>
                 <a:ea typeface="Montserrat" pitchFamily="34" charset="-122"/>
@@ -16473,8 +16473,8 @@
         </p:nvSpPr>
         <p:spPr>
           <a:xfrm>
-            <a:off x="507950" y="4845100"/>
-            <a:ext cx="8127950" cy="19050"/>
+            <a:off x="507950" y="4859387"/>
+            <a:ext cx="8127950" cy="4763"/>
           </a:xfrm>
           <a:prstGeom prst="rect">
             <a:avLst/>
@@ -16632,7 +16632,7 @@
             <a:r>
               <a:rPr lang="en-US" sz="2000" b="1" dirty="0">
                 <a:solidFill>
-                  <a:srgbClr val="807F83"/>
+                  <a:srgbClr val="2D2C2E"/>
                 </a:solidFill>
                 <a:latin typeface="Montserrat" pitchFamily="34" charset="0"/>
                 <a:ea typeface="Montserrat" pitchFamily="34" charset="-122"/>
@@ -16880,7 +16880,7 @@
             </a:avLst>
           </a:prstGeom>
           <a:solidFill>
-            <a:srgbClr val="807F83">
+            <a:srgbClr val="2D2C2E">
               <a:alpha val="7000"/>
             </a:srgbClr>
           </a:solidFill>
@@ -16924,7 +16924,7 @@
             <a:r>
               <a:rPr lang="en-US" sz="1100" b="1" dirty="0">
                 <a:solidFill>
-                  <a:srgbClr val="807F83"/>
+                  <a:srgbClr val="2D2C2E"/>
                 </a:solidFill>
                 <a:latin typeface="Montserrat" pitchFamily="34" charset="0"/>
                 <a:ea typeface="Montserrat" pitchFamily="34" charset="-122"/>
@@ -16944,8 +16944,8 @@
         </p:nvSpPr>
         <p:spPr>
           <a:xfrm>
-            <a:off x="507950" y="4845100"/>
-            <a:ext cx="8127950" cy="19050"/>
+            <a:off x="507950" y="4859387"/>
+            <a:ext cx="8127950" cy="4763"/>
           </a:xfrm>
           <a:prstGeom prst="rect">
             <a:avLst/>
@@ -17145,7 +17145,7 @@
             <a:r>
               <a:rPr lang="en-US" sz="2200" b="1" dirty="0">
                 <a:solidFill>
-                  <a:srgbClr val="807F83"/>
+                  <a:srgbClr val="2D2C2E"/>
                 </a:solidFill>
                 <a:latin typeface="Montserrat" pitchFamily="34" charset="0"/>
                 <a:ea typeface="Montserrat" pitchFamily="34" charset="-122"/>
@@ -17253,13 +17253,13 @@
             <a:r>
               <a:rPr lang="en-US" sz="1100" dirty="0">
                 <a:solidFill>
-                  <a:srgbClr val="807F83"/>
-                </a:solidFill>
-                <a:latin typeface="Montserrat" pitchFamily="34" charset="0"/>
-                <a:ea typeface="Montserrat" pitchFamily="34" charset="-122"/>
-                <a:cs typeface="Montserrat" pitchFamily="34" charset="-120"/>
-              </a:rPr>
-              <a:t>Discovery</a:t>
+                  <a:srgbClr val="2D2C2E"/>
+                </a:solidFill>
+                <a:latin typeface="Montserrat" pitchFamily="34" charset="0"/>
+                <a:ea typeface="Montserrat" pitchFamily="34" charset="-122"/>
+                <a:cs typeface="Montserrat" pitchFamily="34" charset="-120"/>
+              </a:rPr>
+              <a:t>Landscape</a:t>
             </a:r>
             <a:endParaRPr lang="en-US" sz="1100" dirty="0"/>
           </a:p>
@@ -17343,7 +17343,7 @@
                 <a:ea typeface="Montserrat" pitchFamily="34" charset="-122"/>
                 <a:cs typeface="Montserrat" pitchFamily="34" charset="-120"/>
               </a:rPr>
-              <a:t>Research &amp; audit</a:t>
+              <a:t>Map stakeholders</a:t>
             </a:r>
             <a:endParaRPr lang="en-US" sz="800" dirty="0"/>
           </a:p>
@@ -17415,13 +17415,13 @@
             <a:r>
               <a:rPr lang="en-US" sz="1100" dirty="0">
                 <a:solidFill>
-                  <a:srgbClr val="807F83"/>
-                </a:solidFill>
-                <a:latin typeface="Montserrat" pitchFamily="34" charset="0"/>
-                <a:ea typeface="Montserrat" pitchFamily="34" charset="-122"/>
-                <a:cs typeface="Montserrat" pitchFamily="34" charset="-120"/>
-              </a:rPr>
-              <a:t>Strategy</a:t>
+                  <a:srgbClr val="2D2C2E"/>
+                </a:solidFill>
+                <a:latin typeface="Montserrat" pitchFamily="34" charset="0"/>
+                <a:ea typeface="Montserrat" pitchFamily="34" charset="-122"/>
+                <a:cs typeface="Montserrat" pitchFamily="34" charset="-120"/>
+              </a:rPr>
+              <a:t>Narrative</a:t>
             </a:r>
             <a:endParaRPr lang="en-US" sz="1100" dirty="0"/>
           </a:p>
@@ -17505,7 +17505,7 @@
                 <a:ea typeface="Montserrat" pitchFamily="34" charset="-122"/>
                 <a:cs typeface="Montserrat" pitchFamily="34" charset="-120"/>
               </a:rPr>
-              <a:t>Plan &amp; align</a:t>
+              <a:t>Test &amp; refine</a:t>
             </a:r>
             <a:endParaRPr lang="en-US" sz="800" dirty="0"/>
           </a:p>
@@ -17577,13 +17577,13 @@
             <a:r>
               <a:rPr lang="en-US" sz="1100" dirty="0">
                 <a:solidFill>
-                  <a:srgbClr val="807F83"/>
-                </a:solidFill>
-                <a:latin typeface="Montserrat" pitchFamily="34" charset="0"/>
-                <a:ea typeface="Montserrat" pitchFamily="34" charset="-122"/>
-                <a:cs typeface="Montserrat" pitchFamily="34" charset="-120"/>
-              </a:rPr>
-              <a:t>Build</a:t>
+                  <a:srgbClr val="2D2C2E"/>
+                </a:solidFill>
+                <a:latin typeface="Montserrat" pitchFamily="34" charset="0"/>
+                <a:ea typeface="Montserrat" pitchFamily="34" charset="-122"/>
+                <a:cs typeface="Montserrat" pitchFamily="34" charset="-120"/>
+              </a:rPr>
+              <a:t>Engage</a:t>
             </a:r>
             <a:endParaRPr lang="en-US" sz="1100" dirty="0"/>
           </a:p>
@@ -17667,7 +17667,7 @@
                 <a:ea typeface="Montserrat" pitchFamily="34" charset="-122"/>
                 <a:cs typeface="Montserrat" pitchFamily="34" charset="-120"/>
               </a:rPr>
-              <a:t>Develop &amp; test</a:t>
+              <a:t>Direct briefings</a:t>
             </a:r>
             <a:endParaRPr lang="en-US" sz="800" dirty="0"/>
           </a:p>
@@ -17739,13 +17739,13 @@
             <a:r>
               <a:rPr lang="en-US" sz="1100" dirty="0">
                 <a:solidFill>
-                  <a:srgbClr val="807F83"/>
-                </a:solidFill>
-                <a:latin typeface="Montserrat" pitchFamily="34" charset="0"/>
-                <a:ea typeface="Montserrat" pitchFamily="34" charset="-122"/>
-                <a:cs typeface="Montserrat" pitchFamily="34" charset="-120"/>
-              </a:rPr>
-              <a:t>Launch</a:t>
+                  <a:srgbClr val="2D2C2E"/>
+                </a:solidFill>
+                <a:latin typeface="Montserrat" pitchFamily="34" charset="0"/>
+                <a:ea typeface="Montserrat" pitchFamily="34" charset="-122"/>
+                <a:cs typeface="Montserrat" pitchFamily="34" charset="-120"/>
+              </a:rPr>
+              <a:t>Amplify</a:t>
             </a:r>
             <a:endParaRPr lang="en-US" sz="1100" dirty="0"/>
           </a:p>
@@ -17829,7 +17829,7 @@
                 <a:ea typeface="Montserrat" pitchFamily="34" charset="-122"/>
                 <a:cs typeface="Montserrat" pitchFamily="34" charset="-120"/>
               </a:rPr>
-              <a:t>Deploy &amp; train</a:t>
+              <a:t>Media &amp; allies</a:t>
             </a:r>
             <a:endParaRPr lang="en-US" sz="800" dirty="0"/>
           </a:p>
@@ -17901,13 +17901,13 @@
             <a:r>
               <a:rPr lang="en-US" sz="1100" dirty="0">
                 <a:solidFill>
-                  <a:srgbClr val="807F83"/>
-                </a:solidFill>
-                <a:latin typeface="Montserrat" pitchFamily="34" charset="0"/>
-                <a:ea typeface="Montserrat" pitchFamily="34" charset="-122"/>
-                <a:cs typeface="Montserrat" pitchFamily="34" charset="-120"/>
-              </a:rPr>
-              <a:t>Optimize</a:t>
+                  <a:srgbClr val="2D2C2E"/>
+                </a:solidFill>
+                <a:latin typeface="Montserrat" pitchFamily="34" charset="0"/>
+                <a:ea typeface="Montserrat" pitchFamily="34" charset="-122"/>
+                <a:cs typeface="Montserrat" pitchFamily="34" charset="-120"/>
+              </a:rPr>
+              <a:t>Sustain</a:t>
             </a:r>
             <a:endParaRPr lang="en-US" sz="1100" dirty="0"/>
           </a:p>
@@ -17991,7 +17991,7 @@
                 <a:ea typeface="Montserrat" pitchFamily="34" charset="-122"/>
                 <a:cs typeface="Montserrat" pitchFamily="34" charset="-120"/>
               </a:rPr>
-              <a:t>Measure &amp; refine</a:t>
+              <a:t>Monitor &amp; adapt</a:t>
             </a:r>
             <a:endParaRPr lang="en-US" sz="800" dirty="0"/>
           </a:p>
@@ -18005,8 +18005,8 @@
         </p:nvSpPr>
         <p:spPr>
           <a:xfrm>
-            <a:off x="507950" y="4845100"/>
-            <a:ext cx="8127950" cy="19050"/>
+            <a:off x="507950" y="4859387"/>
+            <a:ext cx="8127950" cy="4763"/>
           </a:xfrm>
           <a:prstGeom prst="rect">
             <a:avLst/>
@@ -18206,7 +18206,7 @@
             <a:r>
               <a:rPr lang="en-US" sz="2200" b="1" dirty="0">
                 <a:solidFill>
-                  <a:srgbClr val="807F83"/>
+                  <a:srgbClr val="2D2C2E"/>
                 </a:solidFill>
                 <a:latin typeface="Montserrat" pitchFamily="34" charset="0"/>
                 <a:ea typeface="Montserrat" pitchFamily="34" charset="-122"/>
@@ -18346,7 +18346,7 @@
             <a:r>
               <a:rPr lang="en-US" sz="1400" dirty="0">
                 <a:solidFill>
-                  <a:srgbClr val="807F83"/>
+                  <a:srgbClr val="2D2C2E"/>
                 </a:solidFill>
                 <a:latin typeface="Montserrat" pitchFamily="34" charset="0"/>
                 <a:ea typeface="Montserrat" pitchFamily="34" charset="-122"/>
@@ -18528,7 +18528,7 @@
             <a:r>
               <a:rPr lang="en-US" sz="1400" dirty="0">
                 <a:solidFill>
-                  <a:srgbClr val="807F83"/>
+                  <a:srgbClr val="2D2C2E"/>
                 </a:solidFill>
                 <a:latin typeface="Montserrat" pitchFamily="34" charset="0"/>
                 <a:ea typeface="Montserrat" pitchFamily="34" charset="-122"/>
@@ -18710,7 +18710,7 @@
             <a:r>
               <a:rPr lang="en-US" sz="1400" dirty="0">
                 <a:solidFill>
-                  <a:srgbClr val="807F83"/>
+                  <a:srgbClr val="2D2C2E"/>
                 </a:solidFill>
                 <a:latin typeface="Montserrat" pitchFamily="34" charset="0"/>
                 <a:ea typeface="Montserrat" pitchFamily="34" charset="-122"/>
@@ -18862,7 +18862,7 @@
             <a:r>
               <a:rPr lang="en-US" sz="1400" dirty="0">
                 <a:solidFill>
-                  <a:srgbClr val="807F83"/>
+                  <a:srgbClr val="2D2C2E"/>
                 </a:solidFill>
                 <a:latin typeface="Montserrat" pitchFamily="34" charset="0"/>
                 <a:ea typeface="Montserrat" pitchFamily="34" charset="-122"/>
@@ -18924,8 +18924,8 @@
         </p:nvSpPr>
         <p:spPr>
           <a:xfrm>
-            <a:off x="507950" y="4845100"/>
-            <a:ext cx="8127950" cy="19050"/>
+            <a:off x="507950" y="4859387"/>
+            <a:ext cx="8127950" cy="4763"/>
           </a:xfrm>
           <a:prstGeom prst="rect">
             <a:avLst/>
@@ -19071,7 +19071,7 @@
         </p:nvSpPr>
         <p:spPr>
           <a:xfrm>
-            <a:off x="762000" y="2322612"/>
+            <a:off x="762000" y="2351187"/>
             <a:ext cx="7772400" cy="142875"/>
           </a:xfrm>
           <a:prstGeom prst="rect">
@@ -19110,7 +19110,7 @@
         </p:nvSpPr>
         <p:spPr>
           <a:xfrm>
-            <a:off x="762000" y="2566988"/>
+            <a:off x="762000" y="2595563"/>
             <a:ext cx="7772400" cy="1097161"/>
           </a:xfrm>
           <a:prstGeom prst="rect">
@@ -19178,8 +19178,8 @@
         </p:nvSpPr>
         <p:spPr>
           <a:xfrm>
-            <a:off x="762000" y="3765649"/>
-            <a:ext cx="1269950" cy="38100"/>
+            <a:off x="762000" y="3794224"/>
+            <a:ext cx="1269950" cy="9525"/>
           </a:xfrm>
           <a:prstGeom prst="rect">
             <a:avLst/>
@@ -19252,8 +19252,8 @@
         </p:nvSpPr>
         <p:spPr>
           <a:xfrm>
-            <a:off x="8023473" y="4629150"/>
-            <a:ext cx="624828" cy="133350"/>
+            <a:off x="7845772" y="4629150"/>
+            <a:ext cx="806083" cy="133350"/>
           </a:xfrm>
           <a:prstGeom prst="rect">
             <a:avLst/>
@@ -19279,7 +19279,7 @@
                 <a:ea typeface="Space Mono" pitchFamily="34" charset="-122"/>
                 <a:cs typeface="Space Mono" pitchFamily="34" charset="-120"/>
               </a:rPr>
-              <a:t>example.com</a:t>
+              <a:t>dukestrategies.eu</a:t>
             </a:r>
             <a:endParaRPr lang="en-US" sz="900" dirty="0"/>
           </a:p>
@@ -19386,7 +19386,7 @@
             <a:r>
               <a:rPr lang="en-US" sz="2000" b="1" dirty="0">
                 <a:solidFill>
-                  <a:srgbClr val="807F83"/>
+                  <a:srgbClr val="2D2C2E"/>
                 </a:solidFill>
                 <a:latin typeface="Montserrat" pitchFamily="34" charset="0"/>
                 <a:ea typeface="Montserrat" pitchFamily="34" charset="-122"/>
@@ -19528,7 +19528,7 @@
             <a:r>
               <a:rPr lang="en-US" sz="1200" dirty="0">
                 <a:solidFill>
-                  <a:srgbClr val="807F83"/>
+                  <a:srgbClr val="2D2C2E"/>
                 </a:solidFill>
                 <a:latin typeface="Montserrat" pitchFamily="34" charset="0"/>
                 <a:ea typeface="Montserrat" pitchFamily="34" charset="-122"/>
@@ -19601,7 +19601,7 @@
             <a:r>
               <a:rPr lang="en-US" sz="1200" dirty="0">
                 <a:solidFill>
-                  <a:srgbClr val="807F83"/>
+                  <a:srgbClr val="2D2C2E"/>
                 </a:solidFill>
                 <a:latin typeface="Montserrat" pitchFamily="34" charset="0"/>
                 <a:ea typeface="Montserrat" pitchFamily="34" charset="-122"/>
@@ -19674,7 +19674,7 @@
             <a:r>
               <a:rPr lang="en-US" sz="1200" dirty="0">
                 <a:solidFill>
-                  <a:srgbClr val="807F83"/>
+                  <a:srgbClr val="2D2C2E"/>
                 </a:solidFill>
                 <a:latin typeface="Montserrat" pitchFamily="34" charset="0"/>
                 <a:ea typeface="Montserrat" pitchFamily="34" charset="-122"/>
@@ -19862,8 +19862,8 @@
         </p:nvSpPr>
         <p:spPr>
           <a:xfrm>
-            <a:off x="507950" y="4845100"/>
-            <a:ext cx="8127950" cy="19050"/>
+            <a:off x="507950" y="4859387"/>
+            <a:ext cx="8127950" cy="4763"/>
           </a:xfrm>
           <a:prstGeom prst="rect">
             <a:avLst/>
@@ -20063,7 +20063,7 @@
             <a:r>
               <a:rPr lang="en-US" sz="2000" b="1" dirty="0">
                 <a:solidFill>
-                  <a:srgbClr val="807F83"/>
+                  <a:srgbClr val="2D2C2E"/>
                 </a:solidFill>
                 <a:latin typeface="Montserrat" pitchFamily="34" charset="0"/>
                 <a:ea typeface="Montserrat" pitchFamily="34" charset="-122"/>
@@ -20606,8 +20606,8 @@
         </p:nvSpPr>
         <p:spPr>
           <a:xfrm>
-            <a:off x="507950" y="4845100"/>
-            <a:ext cx="8127950" cy="19050"/>
+            <a:off x="507950" y="4859387"/>
+            <a:ext cx="8127950" cy="4763"/>
           </a:xfrm>
           <a:prstGeom prst="rect">
             <a:avLst/>
@@ -20807,7 +20807,7 @@
             <a:r>
               <a:rPr lang="en-US" sz="2000" b="1" dirty="0">
                 <a:solidFill>
-                  <a:srgbClr val="807F83"/>
+                  <a:srgbClr val="2D2C2E"/>
                 </a:solidFill>
                 <a:latin typeface="Montserrat" pitchFamily="34" charset="0"/>
                 <a:ea typeface="Montserrat" pitchFamily="34" charset="-122"/>
@@ -21077,7 +21077,7 @@
             <a:r>
               <a:rPr lang="en-US" sz="1100" b="1" dirty="0">
                 <a:solidFill>
-                  <a:srgbClr val="807F83"/>
+                  <a:srgbClr val="2D2C2E"/>
                 </a:solidFill>
                 <a:latin typeface="Montserrat" pitchFamily="34" charset="0"/>
                 <a:ea typeface="Montserrat" pitchFamily="34" charset="-122"/>
@@ -21097,8 +21097,8 @@
         </p:nvSpPr>
         <p:spPr>
           <a:xfrm>
-            <a:off x="507950" y="4845100"/>
-            <a:ext cx="8127950" cy="19050"/>
+            <a:off x="507950" y="4859387"/>
+            <a:ext cx="8127950" cy="4763"/>
           </a:xfrm>
           <a:prstGeom prst="rect">
             <a:avLst/>
@@ -21298,7 +21298,7 @@
             <a:r>
               <a:rPr lang="en-US" sz="2000" b="1" dirty="0">
                 <a:solidFill>
-                  <a:srgbClr val="807F83"/>
+                  <a:srgbClr val="2D2C2E"/>
                 </a:solidFill>
                 <a:latin typeface="Montserrat" pitchFamily="34" charset="0"/>
                 <a:ea typeface="Montserrat" pitchFamily="34" charset="-122"/>
@@ -21403,7 +21403,7 @@
             <a:r>
               <a:rPr lang="en-US" sz="900" dirty="0">
                 <a:solidFill>
-                  <a:srgbClr val="807F83"/>
+                  <a:srgbClr val="2D2C2E"/>
                 </a:solidFill>
                 <a:latin typeface="Montserrat" pitchFamily="34" charset="0"/>
                 <a:ea typeface="Montserrat" pitchFamily="34" charset="-122"/>
@@ -21508,7 +21508,7 @@
             <a:r>
               <a:rPr lang="en-US" sz="900" dirty="0">
                 <a:solidFill>
-                  <a:srgbClr val="807F83"/>
+                  <a:srgbClr val="2D2C2E"/>
                 </a:solidFill>
                 <a:latin typeface="Montserrat" pitchFamily="34" charset="0"/>
                 <a:ea typeface="Montserrat" pitchFamily="34" charset="-122"/>
@@ -21613,7 +21613,7 @@
             <a:r>
               <a:rPr lang="en-US" sz="900" dirty="0">
                 <a:solidFill>
-                  <a:srgbClr val="807F83"/>
+                  <a:srgbClr val="2D2C2E"/>
                 </a:solidFill>
                 <a:latin typeface="Montserrat" pitchFamily="34" charset="0"/>
                 <a:ea typeface="Montserrat" pitchFamily="34" charset="-122"/>
@@ -21718,7 +21718,7 @@
             <a:r>
               <a:rPr lang="en-US" sz="900" dirty="0">
                 <a:solidFill>
-                  <a:srgbClr val="807F83"/>
+                  <a:srgbClr val="2D2C2E"/>
                 </a:solidFill>
                 <a:latin typeface="Montserrat" pitchFamily="34" charset="0"/>
                 <a:ea typeface="Montserrat" pitchFamily="34" charset="-122"/>
@@ -21823,7 +21823,7 @@
             <a:r>
               <a:rPr lang="en-US" sz="900" dirty="0">
                 <a:solidFill>
-                  <a:srgbClr val="807F83"/>
+                  <a:srgbClr val="2D2C2E"/>
                 </a:solidFill>
                 <a:latin typeface="Montserrat" pitchFamily="34" charset="0"/>
                 <a:ea typeface="Montserrat" pitchFamily="34" charset="-122"/>
@@ -21928,7 +21928,7 @@
             <a:r>
               <a:rPr lang="en-US" sz="900" dirty="0">
                 <a:solidFill>
-                  <a:srgbClr val="807F83"/>
+                  <a:srgbClr val="2D2C2E"/>
                 </a:solidFill>
                 <a:latin typeface="Montserrat" pitchFamily="34" charset="0"/>
                 <a:ea typeface="Montserrat" pitchFamily="34" charset="-122"/>
@@ -22019,8 +22019,8 @@
         </p:nvSpPr>
         <p:spPr>
           <a:xfrm>
-            <a:off x="507950" y="4845100"/>
-            <a:ext cx="8127950" cy="19050"/>
+            <a:off x="507950" y="4859387"/>
+            <a:ext cx="8127950" cy="4763"/>
           </a:xfrm>
           <a:prstGeom prst="rect">
             <a:avLst/>
@@ -22166,7 +22166,7 @@
         </p:nvSpPr>
         <p:spPr>
           <a:xfrm>
-            <a:off x="762000" y="2087761"/>
+            <a:off x="762000" y="2116336"/>
             <a:ext cx="7772400" cy="142875"/>
           </a:xfrm>
           <a:prstGeom prst="rect">
@@ -22205,7 +22205,7 @@
         </p:nvSpPr>
         <p:spPr>
           <a:xfrm>
-            <a:off x="762000" y="2332137"/>
+            <a:off x="762000" y="2360712"/>
             <a:ext cx="7772400" cy="975420"/>
           </a:xfrm>
           <a:prstGeom prst="rect">
@@ -22273,8 +22273,8 @@
         </p:nvSpPr>
         <p:spPr>
           <a:xfrm>
-            <a:off x="762000" y="3409057"/>
-            <a:ext cx="1269950" cy="38100"/>
+            <a:off x="762000" y="3437632"/>
+            <a:ext cx="1269950" cy="9525"/>
           </a:xfrm>
           <a:prstGeom prst="rect">
             <a:avLst/>
@@ -22497,7 +22497,7 @@
         <p:spPr>
           <a:xfrm>
             <a:off x="762000" y="2214860"/>
-            <a:ext cx="1015901" cy="38100"/>
+            <a:ext cx="1015901" cy="9525"/>
           </a:xfrm>
           <a:prstGeom prst="rect">
             <a:avLst/>
@@ -22526,7 +22526,7 @@
         </p:nvSpPr>
         <p:spPr>
           <a:xfrm>
-            <a:off x="762000" y="2405360"/>
+            <a:off x="762000" y="2376785"/>
             <a:ext cx="4145179" cy="487561"/>
           </a:xfrm>
           <a:prstGeom prst="rect">
@@ -22624,7 +22624,7 @@
       </p:grpSpPr>
       <p:pic>
         <p:nvPicPr>
-          <p:cNvPr id="2" name="Image 0" descr="/Users/williammasquelier/Repositories/stromy-org/brand-tokens/clients/dukestrategies/templates/pptx/_processed/Erasmusbrug_zwart.tinted-overlay.jpg">    </p:cNvPr>
+          <p:cNvPr id="2" name="Image 0" descr="/Users/williammasquelier/Repositories/stromy-org/brand-tokens/clients/dukestrategies/templates/pptx/_processed/Erasmusbrug_zwart.bw-accent.jpg">    </p:cNvPr>
           <p:cNvPicPr>
             <a:picLocks noChangeAspect="1"/>
           </p:cNvPicPr>
@@ -22718,7 +22718,7 @@
             <a:r>
               <a:rPr lang="en-US" sz="2200" b="1" dirty="0">
                 <a:solidFill>
-                  <a:srgbClr val="807F83"/>
+                  <a:srgbClr val="2D2C2E"/>
                 </a:solidFill>
                 <a:latin typeface="Montserrat" pitchFamily="34" charset="0"/>
                 <a:ea typeface="Montserrat" pitchFamily="34" charset="-122"/>
@@ -22739,7 +22739,7 @@
         <p:spPr>
           <a:xfrm>
             <a:off x="4698950" y="1443038"/>
-            <a:ext cx="634901" cy="38100"/>
+            <a:ext cx="634901" cy="9525"/>
           </a:xfrm>
           <a:prstGeom prst="rect">
             <a:avLst/>
@@ -22768,7 +22768,7 @@
         </p:nvSpPr>
         <p:spPr>
           <a:xfrm>
-            <a:off x="4698950" y="1633538"/>
+            <a:off x="4698950" y="1604963"/>
             <a:ext cx="4015689" cy="447080"/>
           </a:xfrm>
           <a:prstGeom prst="rect">
@@ -22813,8 +22813,8 @@
         </p:nvSpPr>
         <p:spPr>
           <a:xfrm>
-            <a:off x="507950" y="4845100"/>
-            <a:ext cx="8127950" cy="19050"/>
+            <a:off x="507950" y="4859387"/>
+            <a:ext cx="8127950" cy="4763"/>
           </a:xfrm>
           <a:prstGeom prst="rect">
             <a:avLst/>
@@ -23017,7 +23017,7 @@
             <a:r>
               <a:rPr lang="en-US" sz="2200" b="1" dirty="0">
                 <a:solidFill>
-                  <a:srgbClr val="807F83"/>
+                  <a:srgbClr val="2D2C2E"/>
                 </a:solidFill>
                 <a:latin typeface="Montserrat" pitchFamily="34" charset="0"/>
                 <a:ea typeface="Montserrat" pitchFamily="34" charset="-122"/>
@@ -23038,7 +23038,7 @@
         <p:spPr>
           <a:xfrm>
             <a:off x="507950" y="1443038"/>
-            <a:ext cx="634901" cy="38100"/>
+            <a:ext cx="634901" cy="9525"/>
           </a:xfrm>
           <a:prstGeom prst="rect">
             <a:avLst/>
@@ -23067,7 +23067,7 @@
         </p:nvSpPr>
         <p:spPr>
           <a:xfrm>
-            <a:off x="507950" y="1633538"/>
+            <a:off x="507950" y="1604963"/>
             <a:ext cx="4015689" cy="447080"/>
           </a:xfrm>
           <a:prstGeom prst="rect">
@@ -23106,7 +23106,7 @@
       </p:sp>
       <p:pic>
         <p:nvPicPr>
-          <p:cNvPr id="6" name="Image 0" descr="/Users/williammasquelier/Repositories/stromy-org/brand-tokens/clients/dukestrategies/templates/pptx/_processed/Nesciobrug.tinted-overlay.jpg">    </p:cNvPr>
+          <p:cNvPr id="6" name="Image 0" descr="/Users/williammasquelier/Repositories/stromy-org/brand-tokens/clients/dukestrategies/templates/pptx/_processed/Nesciobrug.bw-accent.jpg">    </p:cNvPr>
           <p:cNvPicPr>
             <a:picLocks noChangeAspect="1"/>
           </p:cNvPicPr>
@@ -23136,8 +23136,8 @@
         </p:nvSpPr>
         <p:spPr>
           <a:xfrm>
-            <a:off x="507950" y="4845100"/>
-            <a:ext cx="8127950" cy="19050"/>
+            <a:off x="507950" y="4859387"/>
+            <a:ext cx="8127950" cy="4763"/>
           </a:xfrm>
           <a:prstGeom prst="rect">
             <a:avLst/>
@@ -23276,16 +23276,16 @@
         </p:nvSpPr>
         <p:spPr>
           <a:xfrm>
-            <a:off x="1034951" y="1015901"/>
+            <a:off x="1030188" y="1015901"/>
             <a:ext cx="0" cy="1547515"/>
           </a:xfrm>
           <a:prstGeom prst="line">
             <a:avLst/>
           </a:prstGeom>
           <a:noFill/>
-          <a:ln w="38100">
+          <a:ln w="28575">
             <a:solidFill>
-              <a:srgbClr val="FF7F66"/>
+              <a:srgbClr val="FFFFFF"/>
             </a:solidFill>
             <a:prstDash val="solid"/>
           </a:ln>
@@ -23299,8 +23299,8 @@
         </p:nvSpPr>
         <p:spPr>
           <a:xfrm>
-            <a:off x="1358801" y="1015901"/>
-            <a:ext cx="6904381" cy="1172914"/>
+            <a:off x="1349276" y="1015901"/>
+            <a:ext cx="6914096" cy="1172914"/>
           </a:xfrm>
           <a:prstGeom prst="rect">
             <a:avLst/>
@@ -23361,8 +23361,8 @@
         </p:nvSpPr>
         <p:spPr>
           <a:xfrm>
-            <a:off x="1358801" y="2391966"/>
-            <a:ext cx="6904381" cy="171450"/>
+            <a:off x="1349276" y="2391966"/>
+            <a:ext cx="6914096" cy="171450"/>
           </a:xfrm>
           <a:prstGeom prst="rect">
             <a:avLst/>
@@ -23411,7 +23411,7 @@
     <p:bg>
       <p:bgPr>
         <a:solidFill>
-          <a:srgbClr val="807F83"/>
+          <a:srgbClr val="2D2C2E"/>
         </a:solidFill>
       </p:bgPr>
     </p:bg>
@@ -23771,7 +23771,7 @@
             <a:r>
               <a:rPr lang="en-US" sz="2400" b="1" dirty="0">
                 <a:solidFill>
-                  <a:srgbClr val="807F83"/>
+                  <a:srgbClr val="2D2C2E"/>
                 </a:solidFill>
                 <a:latin typeface="Montserrat" pitchFamily="34" charset="0"/>
                 <a:ea typeface="Montserrat" pitchFamily="34" charset="-122"/>
@@ -23872,7 +23872,7 @@
             <a:r>
               <a:rPr lang="en-US" sz="1300" dirty="0">
                 <a:solidFill>
-                  <a:srgbClr val="807F83"/>
+                  <a:srgbClr val="2D2C2E"/>
                 </a:solidFill>
                 <a:latin typeface="Montserrat" pitchFamily="34" charset="0"/>
                 <a:ea typeface="Montserrat" pitchFamily="34" charset="-122"/>
@@ -24015,7 +24015,7 @@
             <a:r>
               <a:rPr lang="en-US" sz="1300" dirty="0">
                 <a:solidFill>
-                  <a:srgbClr val="807F83"/>
+                  <a:srgbClr val="2D2C2E"/>
                 </a:solidFill>
                 <a:latin typeface="Montserrat" pitchFamily="34" charset="0"/>
                 <a:ea typeface="Montserrat" pitchFamily="34" charset="-122"/>
@@ -24158,7 +24158,7 @@
             <a:r>
               <a:rPr lang="en-US" sz="1300" dirty="0">
                 <a:solidFill>
-                  <a:srgbClr val="807F83"/>
+                  <a:srgbClr val="2D2C2E"/>
                 </a:solidFill>
                 <a:latin typeface="Montserrat" pitchFamily="34" charset="0"/>
                 <a:ea typeface="Montserrat" pitchFamily="34" charset="-122"/>
@@ -24301,7 +24301,7 @@
             <a:r>
               <a:rPr lang="en-US" sz="1300" dirty="0">
                 <a:solidFill>
-                  <a:srgbClr val="807F83"/>
+                  <a:srgbClr val="2D2C2E"/>
                 </a:solidFill>
                 <a:latin typeface="Montserrat" pitchFamily="34" charset="0"/>
                 <a:ea typeface="Montserrat" pitchFamily="34" charset="-122"/>
@@ -24444,7 +24444,7 @@
             <a:r>
               <a:rPr lang="en-US" sz="1300" dirty="0">
                 <a:solidFill>
-                  <a:srgbClr val="807F83"/>
+                  <a:srgbClr val="2D2C2E"/>
                 </a:solidFill>
                 <a:latin typeface="Montserrat" pitchFamily="34" charset="0"/>
                 <a:ea typeface="Montserrat" pitchFamily="34" charset="-122"/>
@@ -24506,8 +24506,8 @@
         </p:nvSpPr>
         <p:spPr>
           <a:xfrm>
-            <a:off x="507950" y="4845100"/>
-            <a:ext cx="8127950" cy="19050"/>
+            <a:off x="507950" y="4859387"/>
+            <a:ext cx="8127950" cy="4763"/>
           </a:xfrm>
           <a:prstGeom prst="rect">
             <a:avLst/>
@@ -24707,7 +24707,7 @@
             <a:r>
               <a:rPr lang="en-US" sz="2200" b="1" dirty="0">
                 <a:solidFill>
-                  <a:srgbClr val="807F83"/>
+                  <a:srgbClr val="2D2C2E"/>
                 </a:solidFill>
                 <a:latin typeface="Montserrat" pitchFamily="34" charset="0"/>
                 <a:ea typeface="Montserrat" pitchFamily="34" charset="-122"/>
@@ -24788,7 +24788,7 @@
             <a:r>
               <a:rPr lang="en-US" sz="1300" dirty="0">
                 <a:solidFill>
-                  <a:srgbClr val="807F83"/>
+                  <a:srgbClr val="2D2C2E"/>
                 </a:solidFill>
                 <a:latin typeface="Montserrat" pitchFamily="34" charset="0"/>
                 <a:ea typeface="Montserrat" pitchFamily="34" charset="-122"/>
@@ -24956,7 +24956,7 @@
             <a:r>
               <a:rPr lang="en-US" sz="1300" dirty="0">
                 <a:solidFill>
-                  <a:srgbClr val="807F83"/>
+                  <a:srgbClr val="2D2C2E"/>
                 </a:solidFill>
                 <a:latin typeface="Montserrat" pitchFamily="34" charset="0"/>
                 <a:ea typeface="Montserrat" pitchFamily="34" charset="-122"/>
@@ -25124,7 +25124,7 @@
             <a:r>
               <a:rPr lang="en-US" sz="1300" dirty="0">
                 <a:solidFill>
-                  <a:srgbClr val="807F83"/>
+                  <a:srgbClr val="2D2C2E"/>
                 </a:solidFill>
                 <a:latin typeface="Montserrat" pitchFamily="34" charset="0"/>
                 <a:ea typeface="Montserrat" pitchFamily="34" charset="-122"/>
@@ -25231,8 +25231,8 @@
         </p:nvSpPr>
         <p:spPr>
           <a:xfrm>
-            <a:off x="507950" y="4845100"/>
-            <a:ext cx="8127950" cy="19050"/>
+            <a:off x="507950" y="4859387"/>
+            <a:ext cx="8127950" cy="4763"/>
           </a:xfrm>
           <a:prstGeom prst="rect">
             <a:avLst/>
@@ -25432,7 +25432,7 @@
             <a:r>
               <a:rPr lang="en-US" sz="2200" b="1" dirty="0">
                 <a:solidFill>
-                  <a:srgbClr val="807F83"/>
+                  <a:srgbClr val="2D2C2E"/>
                 </a:solidFill>
                 <a:latin typeface="Montserrat" pitchFamily="34" charset="0"/>
                 <a:ea typeface="Montserrat" pitchFamily="34" charset="-122"/>
@@ -25513,7 +25513,7 @@
             <a:r>
               <a:rPr lang="en-US" sz="1200" dirty="0">
                 <a:solidFill>
-                  <a:srgbClr val="807F83"/>
+                  <a:srgbClr val="2D2C2E"/>
                 </a:solidFill>
                 <a:latin typeface="Montserrat" pitchFamily="34" charset="0"/>
                 <a:ea typeface="Montserrat" pitchFamily="34" charset="-122"/>
@@ -25636,7 +25636,7 @@
             <a:r>
               <a:rPr lang="en-US" sz="1200" dirty="0">
                 <a:solidFill>
-                  <a:srgbClr val="807F83"/>
+                  <a:srgbClr val="2D2C2E"/>
                 </a:solidFill>
                 <a:latin typeface="Montserrat" pitchFamily="34" charset="0"/>
                 <a:ea typeface="Montserrat" pitchFamily="34" charset="-122"/>
@@ -25759,7 +25759,7 @@
             <a:r>
               <a:rPr lang="en-US" sz="1200" dirty="0">
                 <a:solidFill>
-                  <a:srgbClr val="807F83"/>
+                  <a:srgbClr val="2D2C2E"/>
                 </a:solidFill>
                 <a:latin typeface="Montserrat" pitchFamily="34" charset="0"/>
                 <a:ea typeface="Montserrat" pitchFamily="34" charset="-122"/>
@@ -25882,7 +25882,7 @@
             <a:r>
               <a:rPr lang="en-US" sz="1200" dirty="0">
                 <a:solidFill>
-                  <a:srgbClr val="807F83"/>
+                  <a:srgbClr val="2D2C2E"/>
                 </a:solidFill>
                 <a:latin typeface="Montserrat" pitchFamily="34" charset="0"/>
                 <a:ea typeface="Montserrat" pitchFamily="34" charset="-122"/>
@@ -25944,8 +25944,8 @@
         </p:nvSpPr>
         <p:spPr>
           <a:xfrm>
-            <a:off x="507950" y="4845100"/>
-            <a:ext cx="8127950" cy="19050"/>
+            <a:off x="507950" y="4859387"/>
+            <a:ext cx="8127950" cy="4763"/>
           </a:xfrm>
           <a:prstGeom prst="rect">
             <a:avLst/>
@@ -26145,7 +26145,7 @@
             <a:r>
               <a:rPr lang="en-US" sz="2200" b="1" dirty="0">
                 <a:solidFill>
-                  <a:srgbClr val="807F83"/>
+                  <a:srgbClr val="2D2C2E"/>
                 </a:solidFill>
                 <a:latin typeface="Montserrat" pitchFamily="34" charset="0"/>
                 <a:ea typeface="Montserrat" pitchFamily="34" charset="-122"/>
@@ -26221,7 +26221,7 @@
             <a:r>
               <a:rPr lang="en-US" sz="1200" dirty="0">
                 <a:solidFill>
-                  <a:srgbClr val="807F83"/>
+                  <a:srgbClr val="2D2C2E"/>
                 </a:solidFill>
                 <a:latin typeface="Montserrat" pitchFamily="34" charset="0"/>
                 <a:ea typeface="Montserrat" pitchFamily="34" charset="-122"/>
@@ -26342,7 +26342,7 @@
             <a:r>
               <a:rPr lang="en-US" sz="1200" dirty="0">
                 <a:solidFill>
-                  <a:srgbClr val="807F83"/>
+                  <a:srgbClr val="2D2C2E"/>
                 </a:solidFill>
                 <a:latin typeface="Montserrat" pitchFamily="34" charset="0"/>
                 <a:ea typeface="Montserrat" pitchFamily="34" charset="-122"/>
@@ -26463,7 +26463,7 @@
             <a:r>
               <a:rPr lang="en-US" sz="1200" dirty="0">
                 <a:solidFill>
-                  <a:srgbClr val="807F83"/>
+                  <a:srgbClr val="2D2C2E"/>
                 </a:solidFill>
                 <a:latin typeface="Montserrat" pitchFamily="34" charset="0"/>
                 <a:ea typeface="Montserrat" pitchFamily="34" charset="-122"/>
@@ -26584,7 +26584,7 @@
             <a:r>
               <a:rPr lang="en-US" sz="1200" dirty="0">
                 <a:solidFill>
-                  <a:srgbClr val="807F83"/>
+                  <a:srgbClr val="2D2C2E"/>
                 </a:solidFill>
                 <a:latin typeface="Montserrat" pitchFamily="34" charset="0"/>
                 <a:ea typeface="Montserrat" pitchFamily="34" charset="-122"/>
@@ -26705,7 +26705,7 @@
             <a:r>
               <a:rPr lang="en-US" sz="1200" dirty="0">
                 <a:solidFill>
-                  <a:srgbClr val="807F83"/>
+                  <a:srgbClr val="2D2C2E"/>
                 </a:solidFill>
                 <a:latin typeface="Montserrat" pitchFamily="34" charset="0"/>
                 <a:ea typeface="Montserrat" pitchFamily="34" charset="-122"/>
@@ -26826,7 +26826,7 @@
             <a:r>
               <a:rPr lang="en-US" sz="1200" dirty="0">
                 <a:solidFill>
-                  <a:srgbClr val="807F83"/>
+                  <a:srgbClr val="2D2C2E"/>
                 </a:solidFill>
                 <a:latin typeface="Montserrat" pitchFamily="34" charset="0"/>
                 <a:ea typeface="Montserrat" pitchFamily="34" charset="-122"/>
@@ -26891,8 +26891,8 @@
         </p:nvSpPr>
         <p:spPr>
           <a:xfrm>
-            <a:off x="507950" y="4845100"/>
-            <a:ext cx="8127950" cy="19050"/>
+            <a:off x="507950" y="4859387"/>
+            <a:ext cx="8127950" cy="4763"/>
           </a:xfrm>
           <a:prstGeom prst="rect">
             <a:avLst/>
@@ -27050,7 +27050,7 @@
             <a:r>
               <a:rPr lang="en-US" sz="1800" b="1" dirty="0">
                 <a:solidFill>
-                  <a:srgbClr val="807F83"/>
+                  <a:srgbClr val="2D2C2E"/>
                 </a:solidFill>
                 <a:latin typeface="Montserrat" pitchFamily="34" charset="0"/>
                 <a:ea typeface="Montserrat" pitchFamily="34" charset="-122"/>
@@ -27126,7 +27126,7 @@
             <a:r>
               <a:rPr lang="en-US" sz="1000" dirty="0">
                 <a:solidFill>
-                  <a:srgbClr val="807F83"/>
+                  <a:srgbClr val="2D2C2E"/>
                 </a:solidFill>
                 <a:latin typeface="Montserrat" pitchFamily="34" charset="0"/>
                 <a:ea typeface="Montserrat" pitchFamily="34" charset="-122"/>
@@ -27202,7 +27202,7 @@
             <a:r>
               <a:rPr lang="en-US" sz="1000" dirty="0">
                 <a:solidFill>
-                  <a:srgbClr val="807F83"/>
+                  <a:srgbClr val="2D2C2E"/>
                 </a:solidFill>
                 <a:latin typeface="Montserrat" pitchFamily="34" charset="0"/>
                 <a:ea typeface="Montserrat" pitchFamily="34" charset="-122"/>
@@ -27278,7 +27278,7 @@
             <a:r>
               <a:rPr lang="en-US" sz="1000" dirty="0">
                 <a:solidFill>
-                  <a:srgbClr val="807F83"/>
+                  <a:srgbClr val="2D2C2E"/>
                 </a:solidFill>
                 <a:latin typeface="Montserrat" pitchFamily="34" charset="0"/>
                 <a:ea typeface="Montserrat" pitchFamily="34" charset="-122"/>
@@ -27354,7 +27354,7 @@
             <a:r>
               <a:rPr lang="en-US" sz="1000" dirty="0">
                 <a:solidFill>
-                  <a:srgbClr val="807F83"/>
+                  <a:srgbClr val="2D2C2E"/>
                 </a:solidFill>
                 <a:latin typeface="Montserrat" pitchFamily="34" charset="0"/>
                 <a:ea typeface="Montserrat" pitchFamily="34" charset="-122"/>
@@ -27430,7 +27430,7 @@
             <a:r>
               <a:rPr lang="en-US" sz="1000" dirty="0">
                 <a:solidFill>
-                  <a:srgbClr val="807F83"/>
+                  <a:srgbClr val="2D2C2E"/>
                 </a:solidFill>
                 <a:latin typeface="Montserrat" pitchFamily="34" charset="0"/>
                 <a:ea typeface="Montserrat" pitchFamily="34" charset="-122"/>
@@ -27506,7 +27506,7 @@
             <a:r>
               <a:rPr lang="en-US" sz="1000" dirty="0">
                 <a:solidFill>
-                  <a:srgbClr val="807F83"/>
+                  <a:srgbClr val="2D2C2E"/>
                 </a:solidFill>
                 <a:latin typeface="Montserrat" pitchFamily="34" charset="0"/>
                 <a:ea typeface="Montserrat" pitchFamily="34" charset="-122"/>
@@ -27582,7 +27582,7 @@
             <a:r>
               <a:rPr lang="en-US" sz="1000" dirty="0">
                 <a:solidFill>
-                  <a:srgbClr val="807F83"/>
+                  <a:srgbClr val="2D2C2E"/>
                 </a:solidFill>
                 <a:latin typeface="Montserrat" pitchFamily="34" charset="0"/>
                 <a:ea typeface="Montserrat" pitchFamily="34" charset="-122"/>
@@ -27658,7 +27658,7 @@
             <a:r>
               <a:rPr lang="en-US" sz="1000" dirty="0">
                 <a:solidFill>
-                  <a:srgbClr val="807F83"/>
+                  <a:srgbClr val="2D2C2E"/>
                 </a:solidFill>
                 <a:latin typeface="Montserrat" pitchFamily="34" charset="0"/>
                 <a:ea typeface="Montserrat" pitchFamily="34" charset="-122"/>
@@ -27734,7 +27734,7 @@
             <a:r>
               <a:rPr lang="en-US" sz="1000" dirty="0">
                 <a:solidFill>
-                  <a:srgbClr val="807F83"/>
+                  <a:srgbClr val="2D2C2E"/>
                 </a:solidFill>
                 <a:latin typeface="Montserrat" pitchFamily="34" charset="0"/>
                 <a:ea typeface="Montserrat" pitchFamily="34" charset="-122"/>
@@ -27886,7 +27886,7 @@
             <a:r>
               <a:rPr lang="en-US" sz="2200" b="1" dirty="0">
                 <a:solidFill>
-                  <a:srgbClr val="807F83"/>
+                  <a:srgbClr val="2D2C2E"/>
                 </a:solidFill>
                 <a:latin typeface="Montserrat" pitchFamily="34" charset="0"/>
                 <a:ea typeface="Montserrat" pitchFamily="34" charset="-122"/>
@@ -27996,13 +27996,13 @@
             <a:r>
               <a:rPr lang="en-US" sz="1200" dirty="0">
                 <a:solidFill>
-                  <a:srgbClr val="807F83"/>
-                </a:solidFill>
-                <a:latin typeface="Montserrat" pitchFamily="34" charset="0"/>
-                <a:ea typeface="Montserrat" pitchFamily="34" charset="-122"/>
-                <a:cs typeface="Montserrat" pitchFamily="34" charset="-120"/>
-              </a:rPr>
-              <a:t>Review and approve strategic roadmap</a:t>
+                  <a:srgbClr val="2D2C2E"/>
+                </a:solidFill>
+                <a:latin typeface="Montserrat" pitchFamily="34" charset="0"/>
+                <a:ea typeface="Montserrat" pitchFamily="34" charset="-122"/>
+                <a:cs typeface="Montserrat" pitchFamily="34" charset="-120"/>
+              </a:rPr>
+              <a:t>Finalize stakeholder priority map</a:t>
             </a:r>
             <a:endParaRPr lang="en-US" sz="1200" dirty="0"/>
           </a:p>
@@ -28044,7 +28044,7 @@
                 <a:ea typeface="Space Mono" pitchFamily="34" charset="-122"/>
                 <a:cs typeface="Space Mono" pitchFamily="34" charset="-120"/>
               </a:rPr>
-              <a:t>Week 1-2</a:t>
+              <a:t>Week 1</a:t>
             </a:r>
             <a:endParaRPr lang="en-US" sz="900" dirty="0"/>
           </a:p>
@@ -28148,13 +28148,13 @@
             <a:r>
               <a:rPr lang="en-US" sz="1200" dirty="0">
                 <a:solidFill>
-                  <a:srgbClr val="807F83"/>
-                </a:solidFill>
-                <a:latin typeface="Montserrat" pitchFamily="34" charset="0"/>
-                <a:ea typeface="Montserrat" pitchFamily="34" charset="-122"/>
-                <a:cs typeface="Montserrat" pitchFamily="34" charset="-120"/>
-              </a:rPr>
-              <a:t>Mobilize project team and assign workstreams</a:t>
+                  <a:srgbClr val="2D2C2E"/>
+                </a:solidFill>
+                <a:latin typeface="Montserrat" pitchFamily="34" charset="0"/>
+                <a:ea typeface="Montserrat" pitchFamily="34" charset="-122"/>
+                <a:cs typeface="Montserrat" pitchFamily="34" charset="-120"/>
+              </a:rPr>
+              <a:t>Brief top-5 target committee members</a:t>
             </a:r>
             <a:endParaRPr lang="en-US" sz="1200" dirty="0"/>
           </a:p>
@@ -28196,7 +28196,7 @@
                 <a:ea typeface="Space Mono" pitchFamily="34" charset="-122"/>
                 <a:cs typeface="Space Mono" pitchFamily="34" charset="-120"/>
               </a:rPr>
-              <a:t>Week 3</a:t>
+              <a:t>Week 2-4</a:t>
             </a:r>
             <a:endParaRPr lang="en-US" sz="900" dirty="0"/>
           </a:p>
@@ -28300,13 +28300,13 @@
             <a:r>
               <a:rPr lang="en-US" sz="1200" dirty="0">
                 <a:solidFill>
-                  <a:srgbClr val="807F83"/>
-                </a:solidFill>
-                <a:latin typeface="Montserrat" pitchFamily="34" charset="0"/>
-                <a:ea typeface="Montserrat" pitchFamily="34" charset="-122"/>
-                <a:cs typeface="Montserrat" pitchFamily="34" charset="-120"/>
-              </a:rPr>
-              <a:t>Launch Phase 1 discovery workshops</a:t>
+                  <a:srgbClr val="2D2C2E"/>
+                </a:solidFill>
+                <a:latin typeface="Montserrat" pitchFamily="34" charset="0"/>
+                <a:ea typeface="Montserrat" pitchFamily="34" charset="-122"/>
+                <a:cs typeface="Montserrat" pitchFamily="34" charset="-120"/>
+              </a:rPr>
+              <a:t>Lodge formal submission to inquiry</a:t>
             </a:r>
             <a:endParaRPr lang="en-US" sz="1200" dirty="0"/>
           </a:p>
@@ -28348,7 +28348,7 @@
                 <a:ea typeface="Space Mono" pitchFamily="34" charset="-122"/>
                 <a:cs typeface="Space Mono" pitchFamily="34" charset="-120"/>
               </a:rPr>
-              <a:t>Week 4-6</a:t>
+              <a:t>Week 5</a:t>
             </a:r>
             <a:endParaRPr lang="en-US" sz="900" dirty="0"/>
           </a:p>
@@ -28452,13 +28452,13 @@
             <a:r>
               <a:rPr lang="en-US" sz="1200" dirty="0">
                 <a:solidFill>
-                  <a:srgbClr val="807F83"/>
-                </a:solidFill>
-                <a:latin typeface="Montserrat" pitchFamily="34" charset="0"/>
-                <a:ea typeface="Montserrat" pitchFamily="34" charset="-122"/>
-                <a:cs typeface="Montserrat" pitchFamily="34" charset="-120"/>
-              </a:rPr>
-              <a:t>First milestone review and course correction</a:t>
+                  <a:srgbClr val="2D2C2E"/>
+                </a:solidFill>
+                <a:latin typeface="Montserrat" pitchFamily="34" charset="0"/>
+                <a:ea typeface="Montserrat" pitchFamily="34" charset="-122"/>
+                <a:cs typeface="Montserrat" pitchFamily="34" charset="-120"/>
+              </a:rPr>
+              <a:t>Activate coalition amplification sequence</a:t>
             </a:r>
             <a:endParaRPr lang="en-US" sz="1200" dirty="0"/>
           </a:p>
@@ -28500,7 +28500,7 @@
                 <a:ea typeface="Space Mono" pitchFamily="34" charset="-122"/>
                 <a:cs typeface="Space Mono" pitchFamily="34" charset="-120"/>
               </a:rPr>
-              <a:t>Week 8</a:t>
+              <a:t>Week 6-8</a:t>
             </a:r>
             <a:endParaRPr lang="en-US" sz="900" dirty="0"/>
           </a:p>
@@ -28514,8 +28514,8 @@
         </p:nvSpPr>
         <p:spPr>
           <a:xfrm>
-            <a:off x="507950" y="4845100"/>
-            <a:ext cx="8127950" cy="19050"/>
+            <a:off x="507950" y="4859387"/>
+            <a:ext cx="8127950" cy="4763"/>
           </a:xfrm>
           <a:prstGeom prst="rect">
             <a:avLst/>
@@ -28628,7 +28628,7 @@
     <p:bg>
       <p:bgPr>
         <a:solidFill>
-          <a:srgbClr val="807F83"/>
+          <a:srgbClr val="2D2C2E"/>
         </a:solidFill>
       </p:bgPr>
     </p:bg>
@@ -28962,7 +28962,7 @@
         <p:spPr>
           <a:xfrm>
             <a:off x="0" y="0"/>
-            <a:ext cx="9144000" cy="126950"/>
+            <a:ext cx="9144000" cy="25301"/>
           </a:xfrm>
           <a:prstGeom prst="rect">
             <a:avLst/>
@@ -28991,8 +28991,8 @@
         </p:nvSpPr>
         <p:spPr>
           <a:xfrm>
-            <a:off x="1333551" y="2517056"/>
-            <a:ext cx="6476899" cy="1168003"/>
+            <a:off x="1333551" y="2706514"/>
+            <a:ext cx="6476899" cy="817662"/>
           </a:xfrm>
           <a:prstGeom prst="rect">
             <a:avLst/>
@@ -29006,12 +29006,12 @@
           <a:p>
             <a:pPr algn="ctr" indent="0" marL="0">
               <a:lnSpc>
-                <a:spcPts val="4600"/>
+                <a:spcPts val="3220"/>
               </a:lnSpc>
               <a:buNone/>
             </a:pPr>
             <a:r>
-              <a:rPr lang="en-US" sz="4000" dirty="0">
+              <a:rPr lang="en-US" sz="2800" dirty="0">
                 <a:solidFill>
                   <a:srgbClr val="FFFFFF"/>
                 </a:solidFill>
@@ -29021,17 +29021,17 @@
               </a:rPr>
               <a:t>Let’s Build</a:t>
             </a:r>
-            <a:endParaRPr lang="en-US" sz="4000" dirty="0"/>
+            <a:endParaRPr lang="en-US" sz="2800" dirty="0"/>
           </a:p>
           <a:p>
             <a:pPr algn="ctr" indent="0" marL="0">
               <a:lnSpc>
-                <a:spcPts val="4600"/>
+                <a:spcPts val="3220"/>
               </a:lnSpc>
               <a:buNone/>
             </a:pPr>
             <a:r>
-              <a:rPr lang="en-US" sz="4000" dirty="0">
+              <a:rPr lang="en-US" sz="2800" dirty="0">
                 <a:solidFill>
                   <a:srgbClr val="FFFFFF"/>
                 </a:solidFill>
@@ -29041,7 +29041,7 @@
               </a:rPr>
               <a:t>Something Great</a:t>
             </a:r>
-            <a:endParaRPr lang="en-US" sz="4000" dirty="0"/>
+            <a:endParaRPr lang="en-US" sz="2800" dirty="0"/>
           </a:p>
         </p:txBody>
       </p:sp>
@@ -29053,8 +29053,8 @@
         </p:nvSpPr>
         <p:spPr>
           <a:xfrm>
-            <a:off x="1397050" y="3786560"/>
-            <a:ext cx="1015901" cy="38100"/>
+            <a:off x="1397050" y="3625676"/>
+            <a:ext cx="1015901" cy="9525"/>
           </a:xfrm>
           <a:prstGeom prst="rect">
             <a:avLst/>
@@ -29083,7 +29083,7 @@
         </p:nvSpPr>
         <p:spPr>
           <a:xfrm>
-            <a:off x="1333551" y="4027810"/>
+            <a:off x="1333551" y="3838352"/>
             <a:ext cx="6476899" cy="209550"/>
           </a:xfrm>
           <a:prstGeom prst="rect">
@@ -29127,7 +29127,7 @@
         </p:nvSpPr>
         <p:spPr>
           <a:xfrm>
-            <a:off x="1333551" y="4542160"/>
+            <a:off x="1333551" y="4352702"/>
             <a:ext cx="6476899" cy="161925"/>
           </a:xfrm>
           <a:prstGeom prst="rect">
@@ -29152,7 +29152,7 @@
                 <a:ea typeface="Space Mono" pitchFamily="34" charset="-122"/>
                 <a:cs typeface="Space Mono" pitchFamily="34" charset="-120"/>
               </a:rPr>
-              <a:t>example.com</a:t>
+              <a:t>dukestrategies.eu</a:t>
             </a:r>
             <a:endParaRPr lang="en-US" sz="1100" dirty="0"/>
           </a:p>
@@ -29166,7 +29166,7 @@
         </p:nvSpPr>
         <p:spPr>
           <a:xfrm>
-            <a:off x="1333551" y="4754835"/>
+            <a:off x="1333551" y="4565377"/>
             <a:ext cx="6476899" cy="142875"/>
           </a:xfrm>
           <a:prstGeom prst="rect">
@@ -29196,7 +29196,7 @@
                 <a:ea typeface="Space Mono" pitchFamily="34" charset="-122"/>
                 <a:cs typeface="Space Mono" pitchFamily="34" charset="-120"/>
               </a:rPr>
-              <a:t>hello@example.com</a:t>
+              <a:t>hello@dukestrategies.eu</a:t>
             </a:r>
             <a:endParaRPr lang="en-US" sz="1000" dirty="0"/>
           </a:p>
@@ -29216,7 +29216,7 @@
     <p:bg>
       <p:bgPr>
         <a:solidFill>
-          <a:srgbClr val="807F83"/>
+          <a:srgbClr val="2D2C2E"/>
         </a:solidFill>
       </p:bgPr>
     </p:bg>
@@ -29243,7 +29243,7 @@
         <p:spPr>
           <a:xfrm>
             <a:off x="0" y="0"/>
-            <a:ext cx="9144000" cy="126950"/>
+            <a:ext cx="9144000" cy="25301"/>
           </a:xfrm>
           <a:prstGeom prst="rect">
             <a:avLst/>
@@ -29272,8 +29272,8 @@
         </p:nvSpPr>
         <p:spPr>
           <a:xfrm>
-            <a:off x="1333551" y="2662610"/>
-            <a:ext cx="6476899" cy="584002"/>
+            <a:off x="1333551" y="2764482"/>
+            <a:ext cx="6476899" cy="408831"/>
           </a:xfrm>
           <a:prstGeom prst="rect">
             <a:avLst/>
@@ -29287,12 +29287,12 @@
           <a:p>
             <a:pPr algn="ctr" indent="0" marL="0">
               <a:lnSpc>
-                <a:spcPts val="4600"/>
+                <a:spcPts val="3220"/>
               </a:lnSpc>
               <a:buNone/>
             </a:pPr>
             <a:r>
-              <a:rPr lang="en-US" sz="4000" b="1" dirty="0">
+              <a:rPr lang="en-US" sz="2800" b="1" dirty="0">
                 <a:solidFill>
                   <a:srgbClr val="FFFFFF"/>
                 </a:solidFill>
@@ -29302,7 +29302,7 @@
               </a:rPr>
               <a:t>Thank You</a:t>
             </a:r>
-            <a:endParaRPr lang="en-US" sz="4000" dirty="0"/>
+            <a:endParaRPr lang="en-US" sz="2800" dirty="0"/>
           </a:p>
         </p:txBody>
       </p:sp>
@@ -29314,8 +29314,8 @@
         </p:nvSpPr>
         <p:spPr>
           <a:xfrm>
-            <a:off x="1397050" y="3348112"/>
-            <a:ext cx="1015901" cy="38100"/>
+            <a:off x="1397050" y="3274814"/>
+            <a:ext cx="1015901" cy="9525"/>
           </a:xfrm>
           <a:prstGeom prst="rect">
             <a:avLst/>
@@ -29344,7 +29344,7 @@
         </p:nvSpPr>
         <p:spPr>
           <a:xfrm>
-            <a:off x="1333551" y="3589362"/>
+            <a:off x="1333551" y="3487489"/>
             <a:ext cx="6476899" cy="209550"/>
           </a:xfrm>
           <a:prstGeom prst="rect">
@@ -29386,7 +29386,7 @@
         </p:nvSpPr>
         <p:spPr>
           <a:xfrm>
-            <a:off x="1333551" y="4052813"/>
+            <a:off x="1333551" y="3950940"/>
             <a:ext cx="6476899" cy="142875"/>
           </a:xfrm>
           <a:prstGeom prst="rect">
@@ -29414,7 +29414,7 @@
                 <a:ea typeface="Space Mono" pitchFamily="34" charset="-122"/>
                 <a:cs typeface="Space Mono" pitchFamily="34" charset="-120"/>
               </a:rPr>
-              <a:t>example.com</a:t>
+              <a:t>dukestrategies.eu</a:t>
             </a:r>
             <a:endParaRPr lang="en-US" sz="1000" dirty="0"/>
           </a:p>
@@ -29428,7 +29428,7 @@
         </p:nvSpPr>
         <p:spPr>
           <a:xfrm>
-            <a:off x="1333551" y="4246438"/>
+            <a:off x="1333551" y="4144566"/>
             <a:ext cx="6476899" cy="133350"/>
           </a:xfrm>
           <a:prstGeom prst="rect">
@@ -29456,7 +29456,7 @@
                 <a:ea typeface="Space Mono" pitchFamily="34" charset="-122"/>
                 <a:cs typeface="Space Mono" pitchFamily="34" charset="-120"/>
               </a:rPr>
-              <a:t>hello@example.com</a:t>
+              <a:t>hello@dukestrategies.eu</a:t>
             </a:r>
             <a:endParaRPr lang="en-US" sz="900" dirty="0"/>
           </a:p>
@@ -29502,8 +29502,8 @@
         </p:nvSpPr>
         <p:spPr>
           <a:xfrm>
-            <a:off x="1333551" y="1828874"/>
-            <a:ext cx="6476899" cy="933450"/>
+            <a:off x="1333551" y="2076524"/>
+            <a:ext cx="6476899" cy="466725"/>
           </a:xfrm>
           <a:prstGeom prst="rect">
             <a:avLst/>
@@ -29519,7 +29519,7 @@
               <a:buNone/>
             </a:pPr>
             <a:r>
-              <a:rPr lang="en-US" sz="6400" b="1" dirty="0">
+              <a:rPr lang="en-US" sz="3200" b="1" dirty="0">
                 <a:solidFill>
                   <a:srgbClr val="FFFFFF"/>
                 </a:solidFill>
@@ -29529,7 +29529,7 @@
               </a:rPr>
               <a:t>Questions?</a:t>
             </a:r>
-            <a:endParaRPr lang="en-US" sz="6400" dirty="0"/>
+            <a:endParaRPr lang="en-US" sz="3200" dirty="0"/>
           </a:p>
         </p:txBody>
       </p:sp>
@@ -29541,8 +29541,8 @@
         </p:nvSpPr>
         <p:spPr>
           <a:xfrm>
-            <a:off x="1397050" y="2863825"/>
-            <a:ext cx="762000" cy="38100"/>
+            <a:off x="1397050" y="2644750"/>
+            <a:ext cx="762000" cy="9525"/>
           </a:xfrm>
           <a:prstGeom prst="rect">
             <a:avLst/>
@@ -29571,7 +29571,7 @@
         </p:nvSpPr>
         <p:spPr>
           <a:xfrm>
-            <a:off x="1333551" y="3105076"/>
+            <a:off x="1333551" y="2857426"/>
             <a:ext cx="6476899" cy="209550"/>
           </a:xfrm>
           <a:prstGeom prst="rect">
@@ -29601,7 +29601,7 @@
                 <a:ea typeface="Montserrat" pitchFamily="34" charset="-122"/>
                 <a:cs typeface="Montserrat" pitchFamily="34" charset="-120"/>
               </a:rPr>
-              <a:t>hello@example.com</a:t>
+              <a:t>hello@dukestrategies.eu</a:t>
             </a:r>
             <a:endParaRPr lang="en-US" sz="1400" dirty="0"/>
           </a:p>
@@ -29621,7 +29621,7 @@
     <p:bg>
       <p:bgPr>
         <a:solidFill>
-          <a:srgbClr val="807F83"/>
+          <a:srgbClr val="2D2C2E"/>
         </a:solidFill>
       </p:bgPr>
     </p:bg>
@@ -29647,8 +29647,8 @@
         </p:nvSpPr>
         <p:spPr>
           <a:xfrm>
-            <a:off x="762000" y="3356893"/>
-            <a:ext cx="3627069" cy="457200"/>
+            <a:off x="762000" y="3416945"/>
+            <a:ext cx="3627069" cy="365671"/>
           </a:xfrm>
           <a:prstGeom prst="rect">
             <a:avLst/>
@@ -29662,12 +29662,12 @@
           <a:p>
             <a:pPr algn="l" indent="0" marL="0">
               <a:lnSpc>
-                <a:spcPts val="3600"/>
+                <a:spcPts val="2880"/>
               </a:lnSpc>
               <a:buNone/>
             </a:pPr>
             <a:r>
-              <a:rPr lang="en-US" sz="3000" b="1" dirty="0">
+              <a:rPr lang="en-US" sz="2400" b="1" dirty="0">
                 <a:solidFill>
                   <a:srgbClr val="FFFFFF"/>
                 </a:solidFill>
@@ -29677,7 +29677,7 @@
               </a:rPr>
               <a:t>Duke Strategies</a:t>
             </a:r>
-            <a:endParaRPr lang="en-US" sz="3000" dirty="0"/>
+            <a:endParaRPr lang="en-US" sz="2400" dirty="0"/>
           </a:p>
         </p:txBody>
       </p:sp>
@@ -29689,8 +29689,8 @@
         </p:nvSpPr>
         <p:spPr>
           <a:xfrm>
-            <a:off x="762000" y="3915594"/>
-            <a:ext cx="762000" cy="38100"/>
+            <a:off x="762000" y="3884116"/>
+            <a:ext cx="762000" cy="9525"/>
           </a:xfrm>
           <a:prstGeom prst="rect">
             <a:avLst/>
@@ -29719,7 +29719,7 @@
         </p:nvSpPr>
         <p:spPr>
           <a:xfrm>
-            <a:off x="762000" y="4106094"/>
+            <a:off x="762000" y="4046041"/>
             <a:ext cx="3627069" cy="171450"/>
           </a:xfrm>
           <a:prstGeom prst="rect">
@@ -29828,7 +29828,7 @@
                 <a:ea typeface="Space Mono" pitchFamily="34" charset="-122"/>
                 <a:cs typeface="Space Mono" pitchFamily="34" charset="-120"/>
               </a:rPr>
-              <a:t>hello@example.com</a:t>
+              <a:t>hello@dukestrategies.eu</a:t>
             </a:r>
             <a:endParaRPr lang="en-US" sz="1100" dirty="0"/>
           </a:p>
@@ -29909,7 +29909,7 @@
                 <a:ea typeface="Space Mono" pitchFamily="34" charset="-122"/>
                 <a:cs typeface="Space Mono" pitchFamily="34" charset="-120"/>
               </a:rPr>
-              <a:t>example.com</a:t>
+              <a:t>dukestrategies.eu</a:t>
             </a:r>
             <a:endParaRPr lang="en-US" sz="1100" dirty="0"/>
           </a:p>
@@ -30016,7 +30016,7 @@
             <a:r>
               <a:rPr lang="en-US" sz="2200" b="1" dirty="0">
                 <a:solidFill>
-                  <a:srgbClr val="807F83"/>
+                  <a:srgbClr val="2D2C2E"/>
                 </a:solidFill>
                 <a:latin typeface="Montserrat" pitchFamily="34" charset="0"/>
                 <a:ea typeface="Montserrat" pitchFamily="34" charset="-122"/>
@@ -30166,13 +30166,13 @@
             <a:r>
               <a:rPr lang="en-US" sz="1300" dirty="0">
                 <a:solidFill>
-                  <a:srgbClr val="807F83"/>
-                </a:solidFill>
-                <a:latin typeface="Montserrat" pitchFamily="34" charset="0"/>
-                <a:ea typeface="Montserrat" pitchFamily="34" charset="-122"/>
-                <a:cs typeface="Montserrat" pitchFamily="34" charset="-120"/>
-              </a:rPr>
-              <a:t>Executive Summary</a:t>
+                  <a:srgbClr val="2D2C2E"/>
+                </a:solidFill>
+                <a:latin typeface="Montserrat" pitchFamily="34" charset="0"/>
+                <a:ea typeface="Montserrat" pitchFamily="34" charset="-122"/>
+                <a:cs typeface="Montserrat" pitchFamily="34" charset="-120"/>
+              </a:rPr>
+              <a:t>Landscape</a:t>
             </a:r>
             <a:endParaRPr lang="en-US" sz="1300" dirty="0"/>
           </a:p>
@@ -30214,7 +30214,7 @@
                 <a:ea typeface="Montserrat" pitchFamily="34" charset="-122"/>
                 <a:cs typeface="Montserrat" pitchFamily="34" charset="-120"/>
               </a:rPr>
-              <a:t>Key findings</a:t>
+              <a:t>Decision-makers, timing, political context</a:t>
             </a:r>
             <a:endParaRPr lang="en-US" sz="900" dirty="0"/>
           </a:p>
@@ -30358,13 +30358,13 @@
             <a:r>
               <a:rPr lang="en-US" sz="1300" dirty="0">
                 <a:solidFill>
-                  <a:srgbClr val="807F83"/>
-                </a:solidFill>
-                <a:latin typeface="Montserrat" pitchFamily="34" charset="0"/>
-                <a:ea typeface="Montserrat" pitchFamily="34" charset="-122"/>
-                <a:cs typeface="Montserrat" pitchFamily="34" charset="-120"/>
-              </a:rPr>
-              <a:t>Market Analysis</a:t>
+                  <a:srgbClr val="2D2C2E"/>
+                </a:solidFill>
+                <a:latin typeface="Montserrat" pitchFamily="34" charset="0"/>
+                <a:ea typeface="Montserrat" pitchFamily="34" charset="-122"/>
+                <a:cs typeface="Montserrat" pitchFamily="34" charset="-120"/>
+              </a:rPr>
+              <a:t>Stakeholder Map</a:t>
             </a:r>
             <a:endParaRPr lang="en-US" sz="1300" dirty="0"/>
           </a:p>
@@ -30406,7 +30406,7 @@
                 <a:ea typeface="Montserrat" pitchFamily="34" charset="-122"/>
                 <a:cs typeface="Montserrat" pitchFamily="34" charset="-120"/>
               </a:rPr>
-              <a:t>Landscape review</a:t>
+              <a:t>Allies, blockers, movable middle</a:t>
             </a:r>
             <a:endParaRPr lang="en-US" sz="900" dirty="0"/>
           </a:p>
@@ -30550,13 +30550,13 @@
             <a:r>
               <a:rPr lang="en-US" sz="1300" dirty="0">
                 <a:solidFill>
-                  <a:srgbClr val="807F83"/>
-                </a:solidFill>
-                <a:latin typeface="Montserrat" pitchFamily="34" charset="0"/>
-                <a:ea typeface="Montserrat" pitchFamily="34" charset="-122"/>
-                <a:cs typeface="Montserrat" pitchFamily="34" charset="-120"/>
-              </a:rPr>
-              <a:t>Recommendations</a:t>
+                  <a:srgbClr val="2D2C2E"/>
+                </a:solidFill>
+                <a:latin typeface="Montserrat" pitchFamily="34" charset="0"/>
+                <a:ea typeface="Montserrat" pitchFamily="34" charset="-122"/>
+                <a:cs typeface="Montserrat" pitchFamily="34" charset="-120"/>
+              </a:rPr>
+              <a:t>Narrative &amp; Positioning</a:t>
             </a:r>
             <a:endParaRPr lang="en-US" sz="1300" dirty="0"/>
           </a:p>
@@ -30598,7 +30598,7 @@
                 <a:ea typeface="Montserrat" pitchFamily="34" charset="-122"/>
                 <a:cs typeface="Montserrat" pitchFamily="34" charset="-120"/>
               </a:rPr>
-              <a:t>Action plan</a:t>
+              <a:t>The case we want decision-makers to hear</a:t>
             </a:r>
             <a:endParaRPr lang="en-US" sz="900" dirty="0"/>
           </a:p>
@@ -30742,13 +30742,13 @@
             <a:r>
               <a:rPr lang="en-US" sz="1300" dirty="0">
                 <a:solidFill>
-                  <a:srgbClr val="807F83"/>
-                </a:solidFill>
-                <a:latin typeface="Montserrat" pitchFamily="34" charset="0"/>
-                <a:ea typeface="Montserrat" pitchFamily="34" charset="-122"/>
-                <a:cs typeface="Montserrat" pitchFamily="34" charset="-120"/>
-              </a:rPr>
-              <a:t>Implementation</a:t>
+                  <a:srgbClr val="2D2C2E"/>
+                </a:solidFill>
+                <a:latin typeface="Montserrat" pitchFamily="34" charset="0"/>
+                <a:ea typeface="Montserrat" pitchFamily="34" charset="-122"/>
+                <a:cs typeface="Montserrat" pitchFamily="34" charset="-120"/>
+              </a:rPr>
+              <a:t>Engagement Plan</a:t>
             </a:r>
             <a:endParaRPr lang="en-US" sz="1300" dirty="0"/>
           </a:p>
@@ -30790,7 +30790,7 @@
                 <a:ea typeface="Montserrat" pitchFamily="34" charset="-122"/>
                 <a:cs typeface="Montserrat" pitchFamily="34" charset="-120"/>
               </a:rPr>
-              <a:t>Roadmap &amp; milestones</a:t>
+              <a:t>Moments, meetings, and message carriers</a:t>
             </a:r>
             <a:endParaRPr lang="en-US" sz="900" dirty="0"/>
           </a:p>
@@ -30804,8 +30804,8 @@
         </p:nvSpPr>
         <p:spPr>
           <a:xfrm>
-            <a:off x="507950" y="4845100"/>
-            <a:ext cx="8127950" cy="19050"/>
+            <a:off x="507950" y="4859387"/>
+            <a:ext cx="8127950" cy="4763"/>
           </a:xfrm>
           <a:prstGeom prst="rect">
             <a:avLst/>
@@ -30944,7 +30944,7 @@
         </p:nvSpPr>
         <p:spPr>
           <a:xfrm>
-            <a:off x="3333274" y="2106662"/>
+            <a:off x="3333274" y="2120950"/>
             <a:ext cx="2477453" cy="466725"/>
           </a:xfrm>
           <a:prstGeom prst="rect">
@@ -30963,7 +30963,7 @@
             <a:r>
               <a:rPr lang="en-US" sz="3200" b="1" dirty="0">
                 <a:solidFill>
-                  <a:srgbClr val="807F83"/>
+                  <a:srgbClr val="2D2C2E"/>
                 </a:solidFill>
                 <a:latin typeface="Montserrat" pitchFamily="34" charset="0"/>
                 <a:ea typeface="Montserrat" pitchFamily="34" charset="-122"/>
@@ -30983,8 +30983,8 @@
         </p:nvSpPr>
         <p:spPr>
           <a:xfrm>
-            <a:off x="3357563" y="2674888"/>
-            <a:ext cx="762000" cy="38100"/>
+            <a:off x="3357563" y="2689175"/>
+            <a:ext cx="762000" cy="9525"/>
           </a:xfrm>
           <a:prstGeom prst="rect">
             <a:avLst/>
@@ -31013,7 +31013,7 @@
         </p:nvSpPr>
         <p:spPr>
           <a:xfrm>
-            <a:off x="3333274" y="2865388"/>
+            <a:off x="3333274" y="2851100"/>
             <a:ext cx="2477453" cy="171450"/>
           </a:xfrm>
           <a:prstGeom prst="rect">
@@ -31088,7 +31088,7 @@
         <p:spPr>
           <a:xfrm>
             <a:off x="762000" y="1269950"/>
-            <a:ext cx="7772400" cy="1828800"/>
+            <a:ext cx="7772400" cy="635050"/>
           </a:xfrm>
           <a:prstGeom prst="rect">
             <a:avLst/>
@@ -31102,12 +31102,12 @@
           <a:p>
             <a:pPr algn="l" indent="0" marL="0">
               <a:lnSpc>
-                <a:spcPts val="14400"/>
+                <a:spcPts val="5000"/>
               </a:lnSpc>
               <a:buNone/>
             </a:pPr>
             <a:r>
-              <a:rPr lang="en-US" sz="14400" dirty="0">
+              <a:rPr lang="en-US" sz="5000" dirty="0">
                 <a:solidFill>
                   <a:srgbClr val="FFFFFF">
                     <a:alpha val="25000"/>
@@ -31119,7 +31119,7 @@
               </a:rPr>
               <a:t>01</a:t>
             </a:r>
-            <a:endParaRPr lang="en-US" sz="14400" dirty="0"/>
+            <a:endParaRPr lang="en-US" sz="5000" dirty="0"/>
           </a:p>
         </p:txBody>
       </p:sp>
@@ -31131,8 +31131,8 @@
         </p:nvSpPr>
         <p:spPr>
           <a:xfrm>
-            <a:off x="762000" y="3200251"/>
-            <a:ext cx="7772400" cy="581025"/>
+            <a:off x="762000" y="2006501"/>
+            <a:ext cx="7772400" cy="409575"/>
           </a:xfrm>
           <a:prstGeom prst="rect">
             <a:avLst/>
@@ -31151,7 +31151,7 @@
               <a:buNone/>
             </a:pPr>
             <a:r>
-              <a:rPr lang="en-US" sz="4000" b="1" dirty="0">
+              <a:rPr lang="en-US" sz="2800" b="1" dirty="0">
                 <a:solidFill>
                   <a:srgbClr val="FFFFFF"/>
                 </a:solidFill>
@@ -31161,7 +31161,7 @@
               </a:rPr>
               <a:t>Landscape</a:t>
             </a:r>
-            <a:endParaRPr lang="en-US" sz="4000" dirty="0"/>
+            <a:endParaRPr lang="en-US" sz="2800" dirty="0"/>
           </a:p>
         </p:txBody>
       </p:sp>
@@ -31173,8 +31173,8 @@
         </p:nvSpPr>
         <p:spPr>
           <a:xfrm>
-            <a:off x="762000" y="3882777"/>
-            <a:ext cx="1015901" cy="38100"/>
+            <a:off x="762000" y="2517577"/>
+            <a:ext cx="1015901" cy="9525"/>
           </a:xfrm>
           <a:prstGeom prst="rect">
             <a:avLst/>
@@ -31203,7 +31203,7 @@
         </p:nvSpPr>
         <p:spPr>
           <a:xfrm>
-            <a:off x="762000" y="4073277"/>
+            <a:off x="762000" y="2679502"/>
             <a:ext cx="7772400" cy="209550"/>
           </a:xfrm>
           <a:prstGeom prst="rect">
@@ -31287,7 +31287,7 @@
         <p:spPr>
           <a:xfrm>
             <a:off x="762000" y="1269950"/>
-            <a:ext cx="7772400" cy="1828800"/>
+            <a:ext cx="7772400" cy="635050"/>
           </a:xfrm>
           <a:prstGeom prst="rect">
             <a:avLst/>
@@ -31301,12 +31301,12 @@
           <a:p>
             <a:pPr algn="l" indent="0" marL="0">
               <a:lnSpc>
-                <a:spcPts val="14400"/>
+                <a:spcPts val="5000"/>
               </a:lnSpc>
               <a:buNone/>
             </a:pPr>
             <a:r>
-              <a:rPr lang="en-US" sz="14400" dirty="0">
+              <a:rPr lang="en-US" sz="5000" dirty="0">
                 <a:solidFill>
                   <a:srgbClr val="FFFFFF">
                     <a:alpha val="25000"/>
@@ -31318,7 +31318,7 @@
               </a:rPr>
               <a:t>02</a:t>
             </a:r>
-            <a:endParaRPr lang="en-US" sz="14400" dirty="0"/>
+            <a:endParaRPr lang="en-US" sz="5000" dirty="0"/>
           </a:p>
         </p:txBody>
       </p:sp>
@@ -31330,8 +31330,8 @@
         </p:nvSpPr>
         <p:spPr>
           <a:xfrm>
-            <a:off x="762000" y="3200251"/>
-            <a:ext cx="7772400" cy="581025"/>
+            <a:off x="762000" y="2006501"/>
+            <a:ext cx="7772400" cy="409575"/>
           </a:xfrm>
           <a:prstGeom prst="rect">
             <a:avLst/>
@@ -31350,7 +31350,7 @@
               <a:buNone/>
             </a:pPr>
             <a:r>
-              <a:rPr lang="en-US" sz="4000" b="1" dirty="0">
+              <a:rPr lang="en-US" sz="2800" b="1" dirty="0">
                 <a:solidFill>
                   <a:srgbClr val="FFFFFF"/>
                 </a:solidFill>
@@ -31360,7 +31360,7 @@
               </a:rPr>
               <a:t>Stakeholder Map</a:t>
             </a:r>
-            <a:endParaRPr lang="en-US" sz="4000" dirty="0"/>
+            <a:endParaRPr lang="en-US" sz="2800" dirty="0"/>
           </a:p>
         </p:txBody>
       </p:sp>
@@ -31372,8 +31372,8 @@
         </p:nvSpPr>
         <p:spPr>
           <a:xfrm>
-            <a:off x="762000" y="3882777"/>
-            <a:ext cx="1015901" cy="38100"/>
+            <a:off x="762000" y="2517577"/>
+            <a:ext cx="1015901" cy="9525"/>
           </a:xfrm>
           <a:prstGeom prst="rect">
             <a:avLst/>
@@ -31402,7 +31402,7 @@
         </p:nvSpPr>
         <p:spPr>
           <a:xfrm>
-            <a:off x="762000" y="4073277"/>
+            <a:off x="762000" y="2679502"/>
             <a:ext cx="7772400" cy="209550"/>
           </a:xfrm>
           <a:prstGeom prst="rect">
@@ -31539,7 +31539,7 @@
             <a:r>
               <a:rPr lang="en-US" sz="2200" b="1" dirty="0">
                 <a:solidFill>
-                  <a:srgbClr val="807F83"/>
+                  <a:srgbClr val="2D2C2E"/>
                 </a:solidFill>
                 <a:latin typeface="Montserrat" pitchFamily="34" charset="0"/>
                 <a:ea typeface="Montserrat" pitchFamily="34" charset="-122"/>
@@ -31560,7 +31560,7 @@
         <p:spPr>
           <a:xfrm>
             <a:off x="762000" y="1168152"/>
-            <a:ext cx="762000" cy="38100"/>
+            <a:ext cx="762000" cy="9525"/>
           </a:xfrm>
           <a:prstGeom prst="rect">
             <a:avLst/>
@@ -31589,7 +31589,7 @@
         </p:nvSpPr>
         <p:spPr>
           <a:xfrm>
-            <a:off x="762000" y="1409402"/>
+            <a:off x="762000" y="1380827"/>
             <a:ext cx="7772400" cy="517922"/>
           </a:xfrm>
           <a:prstGeom prst="rect">
@@ -31680,7 +31680,7 @@
         </p:nvSpPr>
         <p:spPr>
           <a:xfrm>
-            <a:off x="762000" y="2079724"/>
+            <a:off x="762000" y="2051149"/>
             <a:ext cx="7772400" cy="517922"/>
           </a:xfrm>
           <a:prstGeom prst="rect">
@@ -31748,8 +31748,8 @@
         </p:nvSpPr>
         <p:spPr>
           <a:xfrm>
-            <a:off x="507950" y="4845100"/>
-            <a:ext cx="8127950" cy="19050"/>
+            <a:off x="507950" y="4859387"/>
+            <a:ext cx="8127950" cy="4763"/>
           </a:xfrm>
           <a:prstGeom prst="rect">
             <a:avLst/>
@@ -31949,7 +31949,7 @@
             <a:r>
               <a:rPr lang="en-US" sz="2200" b="1" dirty="0">
                 <a:solidFill>
-                  <a:srgbClr val="807F83"/>
+                  <a:srgbClr val="2D2C2E"/>
                 </a:solidFill>
                 <a:latin typeface="Montserrat" pitchFamily="34" charset="0"/>
                 <a:ea typeface="Montserrat" pitchFamily="34" charset="-122"/>
@@ -31970,7 +31970,7 @@
         <p:spPr>
           <a:xfrm>
             <a:off x="762000" y="1168152"/>
-            <a:ext cx="762000" cy="38100"/>
+            <a:ext cx="762000" cy="9525"/>
           </a:xfrm>
           <a:prstGeom prst="rect">
             <a:avLst/>
@@ -31999,7 +31999,7 @@
         </p:nvSpPr>
         <p:spPr>
           <a:xfrm>
-            <a:off x="762000" y="1358652"/>
+            <a:off x="762000" y="1330077"/>
             <a:ext cx="3886200" cy="731341"/>
           </a:xfrm>
           <a:prstGeom prst="rect">
@@ -32142,8 +32142,8 @@
         </p:nvSpPr>
         <p:spPr>
           <a:xfrm>
-            <a:off x="507950" y="4845100"/>
-            <a:ext cx="8127950" cy="19050"/>
+            <a:off x="507950" y="4859387"/>
+            <a:ext cx="8127950" cy="4763"/>
           </a:xfrm>
           <a:prstGeom prst="rect">
             <a:avLst/>

</xml_diff>